<commit_message>
Fixed slide resolution and allignment
</commit_message>
<xml_diff>
--- a/CEP146NBB_Project1.pptx
+++ b/CEP146NBB_Project1.pptx
@@ -23,16 +23,16 @@
   <p:notesSz cx="6858000" cy="9144000"/>
   <p:embeddedFontLst>
     <p:embeddedFont>
-      <p:font typeface="Alegreya Sans SC"/>
+      <p:font typeface="Alegreya Sans SC" panose="020B0604020202020204" charset="0"/>
       <p:regular r:id="rId13"/>
     </p:embeddedFont>
     <p:embeddedFont>
-      <p:font typeface="Alegreya Sans SC Bold"/>
+      <p:font typeface="Alegreya Sans SC Bold" panose="020B0604020202020204" charset="0"/>
       <p:regular r:id="rId14"/>
       <p:bold r:id="rId15"/>
     </p:embeddedFont>
     <p:embeddedFont>
-      <p:font typeface="Alegreya Sans SC Medium"/>
+      <p:font typeface="Alegreya Sans SC Medium" panose="020B0604020202020204" charset="0"/>
       <p:regular r:id="rId16"/>
     </p:embeddedFont>
     <p:embeddedFont>
@@ -239,7 +239,7 @@
           <a:p>
             <a:fld id="{94BC2B38-408A-8647-991A-B19F79294DCD}" type="datetimeFigureOut">
               <a:rPr lang="en-KR" smtClean="0"/>
-              <a:t>10/18/26</a:t>
+              <a:t>10/18/2026</a:t>
             </a:fld>
             <a:endParaRPr lang="en-KR"/>
           </a:p>
@@ -1023,7 +1023,7 @@
             <a:fld id="{1D8BD707-D9CF-40AE-B4C6-C98DA3205C09}" type="datetimeFigureOut">
               <a:rPr lang="en-US" smtClean="0"/>
               <a:pPr/>
-              <a:t>10/18/26</a:t>
+              <a:t>10/18/2026</a:t>
             </a:fld>
             <a:endParaRPr lang="en-US"/>
           </a:p>
@@ -1188,7 +1188,7 @@
             <a:fld id="{1D8BD707-D9CF-40AE-B4C6-C98DA3205C09}" type="datetimeFigureOut">
               <a:rPr lang="en-US" smtClean="0"/>
               <a:pPr/>
-              <a:t>10/18/26</a:t>
+              <a:t>10/18/2026</a:t>
             </a:fld>
             <a:endParaRPr lang="en-US"/>
           </a:p>
@@ -1363,7 +1363,7 @@
             <a:fld id="{1D8BD707-D9CF-40AE-B4C6-C98DA3205C09}" type="datetimeFigureOut">
               <a:rPr lang="en-US" smtClean="0"/>
               <a:pPr/>
-              <a:t>10/18/26</a:t>
+              <a:t>10/18/2026</a:t>
             </a:fld>
             <a:endParaRPr lang="en-US"/>
           </a:p>
@@ -1528,7 +1528,7 @@
             <a:fld id="{1D8BD707-D9CF-40AE-B4C6-C98DA3205C09}" type="datetimeFigureOut">
               <a:rPr lang="en-US" smtClean="0"/>
               <a:pPr/>
-              <a:t>10/18/26</a:t>
+              <a:t>10/18/2026</a:t>
             </a:fld>
             <a:endParaRPr lang="en-US"/>
           </a:p>
@@ -1770,7 +1770,7 @@
             <a:fld id="{1D8BD707-D9CF-40AE-B4C6-C98DA3205C09}" type="datetimeFigureOut">
               <a:rPr lang="en-US" smtClean="0"/>
               <a:pPr/>
-              <a:t>10/18/26</a:t>
+              <a:t>10/18/2026</a:t>
             </a:fld>
             <a:endParaRPr lang="en-US"/>
           </a:p>
@@ -2052,7 +2052,7 @@
             <a:fld id="{1D8BD707-D9CF-40AE-B4C6-C98DA3205C09}" type="datetimeFigureOut">
               <a:rPr lang="en-US" smtClean="0"/>
               <a:pPr/>
-              <a:t>10/18/26</a:t>
+              <a:t>10/18/2026</a:t>
             </a:fld>
             <a:endParaRPr lang="en-US"/>
           </a:p>
@@ -2468,7 +2468,7 @@
             <a:fld id="{1D8BD707-D9CF-40AE-B4C6-C98DA3205C09}" type="datetimeFigureOut">
               <a:rPr lang="en-US" smtClean="0"/>
               <a:pPr/>
-              <a:t>10/18/26</a:t>
+              <a:t>10/18/2026</a:t>
             </a:fld>
             <a:endParaRPr lang="en-US"/>
           </a:p>
@@ -2582,7 +2582,7 @@
             <a:fld id="{1D8BD707-D9CF-40AE-B4C6-C98DA3205C09}" type="datetimeFigureOut">
               <a:rPr lang="en-US" smtClean="0"/>
               <a:pPr/>
-              <a:t>10/18/26</a:t>
+              <a:t>10/18/2026</a:t>
             </a:fld>
             <a:endParaRPr lang="en-US"/>
           </a:p>
@@ -2674,7 +2674,7 @@
             <a:fld id="{1D8BD707-D9CF-40AE-B4C6-C98DA3205C09}" type="datetimeFigureOut">
               <a:rPr lang="en-US" smtClean="0"/>
               <a:pPr/>
-              <a:t>10/18/26</a:t>
+              <a:t>10/18/2026</a:t>
             </a:fld>
             <a:endParaRPr lang="en-US"/>
           </a:p>
@@ -2946,7 +2946,7 @@
             <a:fld id="{1D8BD707-D9CF-40AE-B4C6-C98DA3205C09}" type="datetimeFigureOut">
               <a:rPr lang="en-US" smtClean="0"/>
               <a:pPr/>
-              <a:t>10/18/26</a:t>
+              <a:t>10/18/2026</a:t>
             </a:fld>
             <a:endParaRPr lang="en-US"/>
           </a:p>
@@ -3195,7 +3195,7 @@
             <a:fld id="{1D8BD707-D9CF-40AE-B4C6-C98DA3205C09}" type="datetimeFigureOut">
               <a:rPr lang="en-US" smtClean="0"/>
               <a:pPr/>
-              <a:t>10/18/26</a:t>
+              <a:t>10/18/2026</a:t>
             </a:fld>
             <a:endParaRPr lang="en-US"/>
           </a:p>
@@ -3403,7 +3403,7 @@
             <a:fld id="{1D8BD707-D9CF-40AE-B4C6-C98DA3205C09}" type="datetimeFigureOut">
               <a:rPr lang="en-US" smtClean="0"/>
               <a:pPr/>
-              <a:t>10/18/26</a:t>
+              <a:t>10/18/2026</a:t>
             </a:fld>
             <a:endParaRPr lang="en-US"/>
           </a:p>
@@ -4373,13 +4373,13 @@
       </p:grpSpPr>
       <p:sp>
         <p:nvSpPr>
-          <p:cNvPr id="2" name="Freeform 2"/>
+          <p:cNvPr id="3" name="Freeform 3"/>
           <p:cNvSpPr/>
           <p:nvPr/>
         </p:nvSpPr>
         <p:spPr>
-          <a:xfrm flipV="1">
-            <a:off x="519025" y="396902"/>
+          <a:xfrm flipH="1">
+            <a:off x="15486600" y="7366014"/>
             <a:ext cx="2359274" cy="2359274"/>
           </a:xfrm>
           <a:custGeom>
@@ -4391,19 +4391,19 @@
             <a:pathLst>
               <a:path w="2359274" h="2359274">
                 <a:moveTo>
+                  <a:pt x="2359274" y="0"/>
+                </a:moveTo>
+                <a:lnTo>
+                  <a:pt x="0" y="0"/>
+                </a:lnTo>
+                <a:lnTo>
                   <a:pt x="0" y="2359274"/>
-                </a:moveTo>
+                </a:lnTo>
                 <a:lnTo>
                   <a:pt x="2359274" y="2359274"/>
                 </a:lnTo>
                 <a:lnTo>
                   <a:pt x="2359274" y="0"/>
-                </a:lnTo>
-                <a:lnTo>
-                  <a:pt x="0" y="0"/>
-                </a:lnTo>
-                <a:lnTo>
-                  <a:pt x="0" y="2359274"/>
                 </a:lnTo>
                 <a:close/>
               </a:path>
@@ -4430,6 +4430,125 @@
           </a:p>
         </p:txBody>
       </p:sp>
+      <p:sp>
+        <p:nvSpPr>
+          <p:cNvPr id="4" name="Freeform 4"/>
+          <p:cNvSpPr/>
+          <p:nvPr/>
+        </p:nvSpPr>
+        <p:spPr>
+          <a:xfrm>
+            <a:off x="14209837" y="-19050"/>
+            <a:ext cx="4114800" cy="4114800"/>
+          </a:xfrm>
+          <a:custGeom>
+            <a:avLst/>
+            <a:gdLst/>
+            <a:ahLst/>
+            <a:cxnLst/>
+            <a:rect l="l" t="t" r="r" b="b"/>
+            <a:pathLst>
+              <a:path w="4114800" h="4114800">
+                <a:moveTo>
+                  <a:pt x="0" y="0"/>
+                </a:moveTo>
+                <a:lnTo>
+                  <a:pt x="4114800" y="0"/>
+                </a:lnTo>
+                <a:lnTo>
+                  <a:pt x="4114800" y="4114800"/>
+                </a:lnTo>
+                <a:lnTo>
+                  <a:pt x="0" y="4114800"/>
+                </a:lnTo>
+                <a:lnTo>
+                  <a:pt x="0" y="0"/>
+                </a:lnTo>
+                <a:close/>
+              </a:path>
+            </a:pathLst>
+          </a:custGeom>
+          <a:blipFill>
+            <a:blip>
+              <a:alphaModFix amt="24000"/>
+              <a:extLst>
+                <a:ext uri="{96DAC541-7B7A-43D3-8B79-37D633B846F1}">
+                  <asvg:svgBlip xmlns:asvg="http://schemas.microsoft.com/office/drawing/2016/SVG/main" r:embed="rId4"/>
+                </a:ext>
+              </a:extLst>
+            </a:blip>
+            <a:stretch>
+              <a:fillRect/>
+            </a:stretch>
+          </a:blipFill>
+        </p:spPr>
+        <p:txBody>
+          <a:bodyPr/>
+          <a:lstStyle/>
+          <a:p>
+            <a:endParaRPr lang="en-CA"/>
+          </a:p>
+        </p:txBody>
+      </p:sp>
+      <p:sp>
+        <p:nvSpPr>
+          <p:cNvPr id="2" name="Freeform 2"/>
+          <p:cNvSpPr/>
+          <p:nvPr/>
+        </p:nvSpPr>
+        <p:spPr>
+          <a:xfrm flipV="1">
+            <a:off x="519025" y="396902"/>
+            <a:ext cx="2359274" cy="2359274"/>
+          </a:xfrm>
+          <a:custGeom>
+            <a:avLst/>
+            <a:gdLst/>
+            <a:ahLst/>
+            <a:cxnLst/>
+            <a:rect l="l" t="t" r="r" b="b"/>
+            <a:pathLst>
+              <a:path w="2359274" h="2359274">
+                <a:moveTo>
+                  <a:pt x="0" y="2359274"/>
+                </a:moveTo>
+                <a:lnTo>
+                  <a:pt x="2359274" y="2359274"/>
+                </a:lnTo>
+                <a:lnTo>
+                  <a:pt x="2359274" y="0"/>
+                </a:lnTo>
+                <a:lnTo>
+                  <a:pt x="0" y="0"/>
+                </a:lnTo>
+                <a:lnTo>
+                  <a:pt x="0" y="2359274"/>
+                </a:lnTo>
+                <a:close/>
+              </a:path>
+            </a:pathLst>
+          </a:custGeom>
+          <a:blipFill>
+            <a:blip>
+              <a:extLst>
+                <a:ext uri="{96DAC541-7B7A-43D3-8B79-37D633B846F1}">
+                  <asvg:svgBlip xmlns:asvg="http://schemas.microsoft.com/office/drawing/2016/SVG/main" r:embed="rId3"/>
+                </a:ext>
+              </a:extLst>
+            </a:blip>
+            <a:stretch>
+              <a:fillRect/>
+            </a:stretch>
+          </a:blipFill>
+        </p:spPr>
+        <p:txBody>
+          <a:bodyPr/>
+          <a:lstStyle/>
+          <a:p>
+            <a:endParaRPr lang="en-CA"/>
+          </a:p>
+        </p:txBody>
+      </p:sp>
       <p:grpSp>
         <p:nvGrpSpPr>
           <p:cNvPr id="8" name="Group 3">
@@ -4444,8 +4563,8 @@
         </p:nvGrpSpPr>
         <p:grpSpPr>
           <a:xfrm>
-            <a:off x="223495" y="1866900"/>
-            <a:ext cx="17841010" cy="8191500"/>
+            <a:off x="223495" y="2411094"/>
+            <a:ext cx="17841010" cy="5247006"/>
             <a:chOff x="0" y="-38100"/>
             <a:chExt cx="1723392" cy="984671"/>
           </a:xfrm>
@@ -4581,125 +4700,6 @@
       </p:grpSp>
       <p:sp>
         <p:nvSpPr>
-          <p:cNvPr id="3" name="Freeform 3"/>
-          <p:cNvSpPr/>
-          <p:nvPr/>
-        </p:nvSpPr>
-        <p:spPr>
-          <a:xfrm flipH="1">
-            <a:off x="15486600" y="7366014"/>
-            <a:ext cx="2359274" cy="2359274"/>
-          </a:xfrm>
-          <a:custGeom>
-            <a:avLst/>
-            <a:gdLst/>
-            <a:ahLst/>
-            <a:cxnLst/>
-            <a:rect l="l" t="t" r="r" b="b"/>
-            <a:pathLst>
-              <a:path w="2359274" h="2359274">
-                <a:moveTo>
-                  <a:pt x="2359274" y="0"/>
-                </a:moveTo>
-                <a:lnTo>
-                  <a:pt x="0" y="0"/>
-                </a:lnTo>
-                <a:lnTo>
-                  <a:pt x="0" y="2359274"/>
-                </a:lnTo>
-                <a:lnTo>
-                  <a:pt x="2359274" y="2359274"/>
-                </a:lnTo>
-                <a:lnTo>
-                  <a:pt x="2359274" y="0"/>
-                </a:lnTo>
-                <a:close/>
-              </a:path>
-            </a:pathLst>
-          </a:custGeom>
-          <a:blipFill>
-            <a:blip>
-              <a:extLst>
-                <a:ext uri="{96DAC541-7B7A-43D3-8B79-37D633B846F1}">
-                  <asvg:svgBlip xmlns:asvg="http://schemas.microsoft.com/office/drawing/2016/SVG/main" r:embed="rId3"/>
-                </a:ext>
-              </a:extLst>
-            </a:blip>
-            <a:stretch>
-              <a:fillRect/>
-            </a:stretch>
-          </a:blipFill>
-        </p:spPr>
-        <p:txBody>
-          <a:bodyPr/>
-          <a:lstStyle/>
-          <a:p>
-            <a:endParaRPr lang="en-CA"/>
-          </a:p>
-        </p:txBody>
-      </p:sp>
-      <p:sp>
-        <p:nvSpPr>
-          <p:cNvPr id="4" name="Freeform 4"/>
-          <p:cNvSpPr/>
-          <p:nvPr/>
-        </p:nvSpPr>
-        <p:spPr>
-          <a:xfrm>
-            <a:off x="14961438" y="-869666"/>
-            <a:ext cx="4114800" cy="4114800"/>
-          </a:xfrm>
-          <a:custGeom>
-            <a:avLst/>
-            <a:gdLst/>
-            <a:ahLst/>
-            <a:cxnLst/>
-            <a:rect l="l" t="t" r="r" b="b"/>
-            <a:pathLst>
-              <a:path w="4114800" h="4114800">
-                <a:moveTo>
-                  <a:pt x="0" y="0"/>
-                </a:moveTo>
-                <a:lnTo>
-                  <a:pt x="4114800" y="0"/>
-                </a:lnTo>
-                <a:lnTo>
-                  <a:pt x="4114800" y="4114800"/>
-                </a:lnTo>
-                <a:lnTo>
-                  <a:pt x="0" y="4114800"/>
-                </a:lnTo>
-                <a:lnTo>
-                  <a:pt x="0" y="0"/>
-                </a:lnTo>
-                <a:close/>
-              </a:path>
-            </a:pathLst>
-          </a:custGeom>
-          <a:blipFill>
-            <a:blip>
-              <a:alphaModFix amt="24000"/>
-              <a:extLst>
-                <a:ext uri="{96DAC541-7B7A-43D3-8B79-37D633B846F1}">
-                  <asvg:svgBlip xmlns:asvg="http://schemas.microsoft.com/office/drawing/2016/SVG/main" r:embed="rId4"/>
-                </a:ext>
-              </a:extLst>
-            </a:blip>
-            <a:stretch>
-              <a:fillRect/>
-            </a:stretch>
-          </a:blipFill>
-        </p:spPr>
-        <p:txBody>
-          <a:bodyPr/>
-          <a:lstStyle/>
-          <a:p>
-            <a:endParaRPr lang="en-CA"/>
-          </a:p>
-        </p:txBody>
-      </p:sp>
-      <p:sp>
-        <p:nvSpPr>
           <p:cNvPr id="5" name="TextBox 5"/>
           <p:cNvSpPr txBox="1"/>
           <p:nvPr/>
@@ -5097,8 +5097,8 @@
         </p:nvSpPr>
         <p:spPr>
           <a:xfrm rot="-5400000">
-            <a:off x="4557186" y="-5988665"/>
-            <a:ext cx="11718479" cy="20832852"/>
+            <a:off x="4000500" y="-4000501"/>
+            <a:ext cx="10287001" cy="18288002"/>
           </a:xfrm>
           <a:custGeom>
             <a:avLst/>
@@ -5156,8 +5156,8 @@
         </p:nvSpPr>
         <p:spPr>
           <a:xfrm flipV="1">
-            <a:off x="519025" y="396902"/>
-            <a:ext cx="2359274" cy="2359274"/>
+            <a:off x="519025" y="685100"/>
+            <a:ext cx="2071075" cy="2071075"/>
           </a:xfrm>
           <a:custGeom>
             <a:avLst/>
@@ -5215,8 +5215,8 @@
         </p:nvSpPr>
         <p:spPr>
           <a:xfrm flipH="1">
-            <a:off x="15486600" y="7366014"/>
-            <a:ext cx="2359274" cy="2359274"/>
+            <a:off x="15486600" y="7654212"/>
+            <a:ext cx="2071075" cy="2071075"/>
           </a:xfrm>
           <a:custGeom>
             <a:avLst/>
@@ -5274,8 +5274,8 @@
         </p:nvSpPr>
         <p:spPr>
           <a:xfrm>
-            <a:off x="15486600" y="396902"/>
-            <a:ext cx="4114800" cy="4114800"/>
+            <a:off x="14716060" y="0"/>
+            <a:ext cx="3612154" cy="3612154"/>
           </a:xfrm>
           <a:custGeom>
             <a:avLst/>
@@ -5334,8 +5334,8 @@
         </p:nvSpPr>
         <p:spPr>
           <a:xfrm>
-            <a:off x="57095" y="7366014"/>
-            <a:ext cx="2693378" cy="2693378"/>
+            <a:off x="57095" y="7695024"/>
+            <a:ext cx="2364367" cy="2364367"/>
           </a:xfrm>
           <a:custGeom>
             <a:avLst/>
@@ -5394,8 +5394,8 @@
         </p:nvGrpSpPr>
         <p:grpSpPr>
           <a:xfrm>
-            <a:off x="271890" y="3699244"/>
-            <a:ext cx="9634110" cy="5887485"/>
+            <a:off x="271890" y="3694533"/>
+            <a:ext cx="8457250" cy="5868567"/>
             <a:chOff x="0" y="0"/>
             <a:chExt cx="2471118" cy="1675100"/>
           </a:xfrm>
@@ -5525,8 +5525,8 @@
         </p:nvSpPr>
         <p:spPr>
           <a:xfrm>
-            <a:off x="2878299" y="700271"/>
-            <a:ext cx="14166815" cy="1102866"/>
+            <a:off x="3820326" y="800100"/>
+            <a:ext cx="10151901" cy="2205732"/>
           </a:xfrm>
           <a:prstGeom prst="rect">
             <a:avLst/>
@@ -5566,8 +5566,8 @@
         </p:nvSpPr>
         <p:spPr>
           <a:xfrm>
-            <a:off x="641898" y="3673088"/>
-            <a:ext cx="9076264" cy="5805885"/>
+            <a:off x="641898" y="3658410"/>
+            <a:ext cx="7967548" cy="5805885"/>
           </a:xfrm>
           <a:prstGeom prst="rect">
             <a:avLst/>
@@ -5749,8 +5749,8 @@
         </p:blipFill>
         <p:spPr>
           <a:xfrm>
-            <a:off x="10439400" y="3944580"/>
-            <a:ext cx="9634114" cy="5397743"/>
+            <a:off x="8790888" y="3658410"/>
+            <a:ext cx="9225221" cy="5904690"/>
           </a:xfrm>
           <a:prstGeom prst="rect">
             <a:avLst/>
@@ -5778,8 +5778,8 @@
         </p:nvSpPr>
         <p:spPr>
           <a:xfrm>
-            <a:off x="10340254" y="9402063"/>
-            <a:ext cx="5507260" cy="369332"/>
+            <a:off x="8790888" y="9748662"/>
+            <a:ext cx="4834517" cy="369332"/>
           </a:xfrm>
           <a:prstGeom prst="rect">
             <a:avLst/>
@@ -5829,8 +5829,8 @@
         </p:nvSpPr>
         <p:spPr>
           <a:xfrm>
-            <a:off x="5143189" y="9670421"/>
-            <a:ext cx="5507260" cy="369332"/>
+            <a:off x="4061760" y="9712108"/>
+            <a:ext cx="4834517" cy="369332"/>
           </a:xfrm>
           <a:prstGeom prst="rect">
             <a:avLst/>
@@ -5919,8 +5919,8 @@
         </p:nvSpPr>
         <p:spPr>
           <a:xfrm rot="-5400000">
-            <a:off x="4557186" y="-5904724"/>
-            <a:ext cx="11718479" cy="20832852"/>
+            <a:off x="3958530" y="-3958531"/>
+            <a:ext cx="10370942" cy="18288002"/>
           </a:xfrm>
           <a:custGeom>
             <a:avLst/>
@@ -5984,8 +5984,8 @@
         </p:nvSpPr>
         <p:spPr>
           <a:xfrm flipV="1">
-            <a:off x="519025" y="396902"/>
-            <a:ext cx="2359274" cy="2359274"/>
+            <a:off x="519025" y="668200"/>
+            <a:ext cx="2071075" cy="2087975"/>
           </a:xfrm>
           <a:custGeom>
             <a:avLst/>
@@ -6049,8 +6049,8 @@
         </p:nvSpPr>
         <p:spPr>
           <a:xfrm flipH="1">
-            <a:off x="15486600" y="7366014"/>
-            <a:ext cx="2359274" cy="2359274"/>
+            <a:off x="15486600" y="7637312"/>
+            <a:ext cx="2071075" cy="2087975"/>
           </a:xfrm>
           <a:custGeom>
             <a:avLst/>
@@ -6114,8 +6114,8 @@
         </p:nvSpPr>
         <p:spPr>
           <a:xfrm>
-            <a:off x="15486600" y="396902"/>
-            <a:ext cx="4114800" cy="4114800"/>
+            <a:off x="14727258" y="-3652"/>
+            <a:ext cx="3612154" cy="3641629"/>
           </a:xfrm>
           <a:custGeom>
             <a:avLst/>
@@ -6180,8 +6180,8 @@
         </p:nvSpPr>
         <p:spPr>
           <a:xfrm>
-            <a:off x="57095" y="7366014"/>
-            <a:ext cx="2693378" cy="2693378"/>
+            <a:off x="57095" y="7675732"/>
+            <a:ext cx="2364367" cy="2383660"/>
           </a:xfrm>
           <a:custGeom>
             <a:avLst/>
@@ -6246,8 +6246,8 @@
         </p:nvSpPr>
         <p:spPr>
           <a:xfrm>
-            <a:off x="2878299" y="479347"/>
-            <a:ext cx="14166815" cy="1102866"/>
+            <a:off x="4748331" y="550443"/>
+            <a:ext cx="8580038" cy="2205732"/>
           </a:xfrm>
           <a:prstGeom prst="rect">
             <a:avLst/>
@@ -6301,8 +6301,8 @@
         </p:blipFill>
         <p:spPr>
           <a:xfrm>
-            <a:off x="3706033" y="2181099"/>
-            <a:ext cx="12511345" cy="7507016"/>
+            <a:off x="3706033" y="3044349"/>
+            <a:ext cx="11072635" cy="6643766"/>
           </a:xfrm>
           <a:prstGeom prst="rect">
             <a:avLst/>
@@ -6330,8 +6330,8 @@
         </p:nvSpPr>
         <p:spPr>
           <a:xfrm>
-            <a:off x="12039601" y="9788357"/>
-            <a:ext cx="4177778" cy="369332"/>
+            <a:off x="12039601" y="9830827"/>
+            <a:ext cx="3667439" cy="738664"/>
           </a:xfrm>
           <a:prstGeom prst="rect">
             <a:avLst/>
@@ -6405,8 +6405,8 @@
         </p:nvSpPr>
         <p:spPr>
           <a:xfrm rot="-5400000">
-            <a:off x="4557186" y="-5988665"/>
-            <a:ext cx="11718479" cy="20832852"/>
+            <a:off x="4000500" y="-4000501"/>
+            <a:ext cx="10287001" cy="18288002"/>
           </a:xfrm>
           <a:custGeom>
             <a:avLst/>
@@ -6464,8 +6464,8 @@
         </p:nvGrpSpPr>
         <p:grpSpPr>
           <a:xfrm>
-            <a:off x="560481" y="2896139"/>
-            <a:ext cx="13280379" cy="2971139"/>
+            <a:off x="560481" y="3259080"/>
+            <a:ext cx="12559859" cy="2265420"/>
             <a:chOff x="0" y="-38100"/>
             <a:chExt cx="1723392" cy="984671"/>
           </a:xfrm>
@@ -6595,8 +6595,8 @@
         </p:nvSpPr>
         <p:spPr>
           <a:xfrm flipV="1">
-            <a:off x="519025" y="396902"/>
-            <a:ext cx="2359274" cy="2359274"/>
+            <a:off x="519025" y="685100"/>
+            <a:ext cx="2071075" cy="2071075"/>
           </a:xfrm>
           <a:custGeom>
             <a:avLst/>
@@ -6654,8 +6654,8 @@
         </p:nvSpPr>
         <p:spPr>
           <a:xfrm flipH="1">
-            <a:off x="15486600" y="7366014"/>
-            <a:ext cx="2359274" cy="2359274"/>
+            <a:off x="15486600" y="7654212"/>
+            <a:ext cx="2071075" cy="2071075"/>
           </a:xfrm>
           <a:custGeom>
             <a:avLst/>
@@ -6713,8 +6713,8 @@
         </p:nvGrpSpPr>
         <p:grpSpPr>
           <a:xfrm>
-            <a:off x="560482" y="6055937"/>
-            <a:ext cx="7745320" cy="4538325"/>
+            <a:off x="560482" y="6085461"/>
+            <a:ext cx="6799185" cy="4087240"/>
             <a:chOff x="-545944" y="-118100"/>
             <a:chExt cx="2089938" cy="851742"/>
           </a:xfrm>
@@ -6834,8 +6834,8 @@
         </p:nvSpPr>
         <p:spPr>
           <a:xfrm>
-            <a:off x="15486600" y="396902"/>
-            <a:ext cx="4114800" cy="4114800"/>
+            <a:off x="14716060" y="-85440"/>
+            <a:ext cx="3612154" cy="3612154"/>
           </a:xfrm>
           <a:custGeom>
             <a:avLst/>
@@ -6894,15 +6894,15 @@
         </p:nvSpPr>
         <p:spPr>
           <a:xfrm>
-            <a:off x="3781860" y="724241"/>
-            <a:ext cx="11882914" cy="1284605"/>
+            <a:off x="3781860" y="881163"/>
+            <a:ext cx="10431349" cy="1127683"/>
           </a:xfrm>
           <a:prstGeom prst="rect">
             <a:avLst/>
           </a:prstGeom>
         </p:spPr>
         <p:txBody>
-          <a:bodyPr lIns="0" tIns="0" rIns="0" bIns="0" rtlCol="0" anchor="t">
+          <a:bodyPr wrap="square" lIns="0" tIns="0" rIns="0" bIns="0" rtlCol="0" anchor="t">
             <a:spAutoFit/>
           </a:bodyPr>
           <a:lstStyle/>
@@ -6935,8 +6935,8 @@
         </p:nvSpPr>
         <p:spPr>
           <a:xfrm>
-            <a:off x="682356" y="3599127"/>
-            <a:ext cx="13040781" cy="2158732"/>
+            <a:off x="682357" y="3862827"/>
+            <a:ext cx="11447776" cy="2158732"/>
           </a:xfrm>
           <a:prstGeom prst="rect">
             <a:avLst/>
@@ -7075,8 +7075,8 @@
         </p:nvSpPr>
         <p:spPr>
           <a:xfrm>
-            <a:off x="4739155" y="3194000"/>
-            <a:ext cx="4923029" cy="410369"/>
+            <a:off x="3750059" y="3484504"/>
+            <a:ext cx="5278948" cy="410369"/>
           </a:xfrm>
           <a:prstGeom prst="rect">
             <a:avLst/>
@@ -7116,8 +7116,8 @@
         </p:nvSpPr>
         <p:spPr>
           <a:xfrm>
-            <a:off x="682356" y="6661316"/>
-            <a:ext cx="7501570" cy="2851230"/>
+            <a:off x="682356" y="6588048"/>
+            <a:ext cx="6585211" cy="2851230"/>
           </a:xfrm>
           <a:prstGeom prst="rect">
             <a:avLst/>
@@ -7282,8 +7282,8 @@
         </p:nvSpPr>
         <p:spPr>
           <a:xfrm>
-            <a:off x="1633499" y="6288596"/>
-            <a:ext cx="5053353" cy="410369"/>
+            <a:off x="1245809" y="6342907"/>
+            <a:ext cx="5072101" cy="410369"/>
           </a:xfrm>
           <a:prstGeom prst="rect">
             <a:avLst/>
@@ -7323,15 +7323,15 @@
         </p:nvSpPr>
         <p:spPr>
           <a:xfrm>
-            <a:off x="4618432" y="1503691"/>
-            <a:ext cx="10209770" cy="1162050"/>
+            <a:off x="4618432" y="1645641"/>
+            <a:ext cx="8962589" cy="961802"/>
           </a:xfrm>
           <a:prstGeom prst="rect">
             <a:avLst/>
           </a:prstGeom>
         </p:spPr>
         <p:txBody>
-          <a:bodyPr lIns="0" tIns="0" rIns="0" bIns="0" rtlCol="0" anchor="t">
+          <a:bodyPr wrap="square" lIns="0" tIns="0" rIns="0" bIns="0" rtlCol="0" anchor="t">
             <a:spAutoFit/>
           </a:bodyPr>
           <a:lstStyle/>
@@ -7382,8 +7382,8 @@
         </p:blipFill>
         <p:spPr>
           <a:xfrm>
-            <a:off x="14384851" y="1503691"/>
-            <a:ext cx="5833408" cy="8024050"/>
+            <a:off x="13411200" y="3371921"/>
+            <a:ext cx="4585942" cy="6308119"/>
           </a:xfrm>
           <a:prstGeom prst="rect">
             <a:avLst/>
@@ -7411,10 +7411,10 @@
         </p:nvGrpSpPr>
         <p:grpSpPr>
           <a:xfrm>
-            <a:off x="8427675" y="5867278"/>
-            <a:ext cx="5413186" cy="4097713"/>
-            <a:chOff x="0" y="-38100"/>
-            <a:chExt cx="1723392" cy="984671"/>
+            <a:off x="7598978" y="5946275"/>
+            <a:ext cx="5580632" cy="3597154"/>
+            <a:chOff x="-300545" y="-38100"/>
+            <a:chExt cx="2023937" cy="984671"/>
           </a:xfrm>
         </p:grpSpPr>
         <p:sp>
@@ -7431,8 +7431,8 @@
           </p:nvSpPr>
           <p:spPr>
             <a:xfrm>
-              <a:off x="0" y="0"/>
-              <a:ext cx="1723392" cy="946571"/>
+              <a:off x="-300545" y="0"/>
+              <a:ext cx="2023937" cy="946571"/>
             </a:xfrm>
             <a:custGeom>
               <a:avLst/>
@@ -7504,7 +7504,7 @@
             <a:bodyPr/>
             <a:lstStyle/>
             <a:p>
-              <a:endParaRPr lang="en-CA"/>
+              <a:endParaRPr lang="en-CA" dirty="0"/>
             </a:p>
           </p:txBody>
         </p:sp>
@@ -7560,8 +7560,8 @@
         </p:nvSpPr>
         <p:spPr>
           <a:xfrm>
-            <a:off x="8588249" y="6277015"/>
-            <a:ext cx="5134888" cy="410369"/>
+            <a:off x="7817800" y="6280787"/>
+            <a:ext cx="5142987" cy="410369"/>
           </a:xfrm>
           <a:prstGeom prst="rect">
             <a:avLst/>
@@ -7607,8 +7607,8 @@
         </p:nvSpPr>
         <p:spPr>
           <a:xfrm>
-            <a:off x="8546654" y="6661316"/>
-            <a:ext cx="5053353" cy="2851230"/>
+            <a:off x="8136815" y="6478912"/>
+            <a:ext cx="4436057" cy="2851230"/>
           </a:xfrm>
           <a:prstGeom prst="rect">
             <a:avLst/>
@@ -7707,8 +7707,8 @@
         </p:nvSpPr>
         <p:spPr>
           <a:xfrm>
-            <a:off x="12971166" y="9691849"/>
-            <a:ext cx="7369171" cy="369332"/>
+            <a:off x="12821143" y="9840203"/>
+            <a:ext cx="6468985" cy="369332"/>
           </a:xfrm>
           <a:prstGeom prst="rect">
             <a:avLst/>
@@ -7777,8 +7777,8 @@
         </p:nvSpPr>
         <p:spPr>
           <a:xfrm rot="-5400000">
-            <a:off x="4557186" y="-5988665"/>
-            <a:ext cx="11718479" cy="20832852"/>
+            <a:off x="4000500" y="-4000501"/>
+            <a:ext cx="10287001" cy="18288002"/>
           </a:xfrm>
           <a:custGeom>
             <a:avLst/>
@@ -7836,8 +7836,8 @@
         </p:nvSpPr>
         <p:spPr>
           <a:xfrm flipV="1">
-            <a:off x="519025" y="396902"/>
-            <a:ext cx="2359274" cy="2359274"/>
+            <a:off x="519025" y="685100"/>
+            <a:ext cx="2071075" cy="2071075"/>
           </a:xfrm>
           <a:custGeom>
             <a:avLst/>
@@ -7895,8 +7895,8 @@
         </p:nvSpPr>
         <p:spPr>
           <a:xfrm flipH="1">
-            <a:off x="15486600" y="7366014"/>
-            <a:ext cx="2359274" cy="2359274"/>
+            <a:off x="15486600" y="7654212"/>
+            <a:ext cx="2071075" cy="2071075"/>
           </a:xfrm>
           <a:custGeom>
             <a:avLst/>
@@ -7954,8 +7954,8 @@
         </p:nvSpPr>
         <p:spPr>
           <a:xfrm>
-            <a:off x="15486600" y="396902"/>
-            <a:ext cx="4114800" cy="4114800"/>
+            <a:off x="15156774" y="-165203"/>
+            <a:ext cx="3612154" cy="3612154"/>
           </a:xfrm>
           <a:custGeom>
             <a:avLst/>
@@ -8014,8 +8014,8 @@
         </p:nvSpPr>
         <p:spPr>
           <a:xfrm>
-            <a:off x="57095" y="7366014"/>
-            <a:ext cx="2693378" cy="2693378"/>
+            <a:off x="57095" y="7695024"/>
+            <a:ext cx="2364367" cy="2364367"/>
           </a:xfrm>
           <a:custGeom>
             <a:avLst/>
@@ -8074,8 +8074,8 @@
         </p:nvGrpSpPr>
         <p:grpSpPr>
           <a:xfrm>
-            <a:off x="715008" y="3854792"/>
-            <a:ext cx="8229600" cy="4855568"/>
+            <a:off x="715007" y="4447926"/>
+            <a:ext cx="8145923" cy="4262433"/>
             <a:chOff x="0" y="0"/>
             <a:chExt cx="2238372" cy="1281401"/>
           </a:xfrm>
@@ -8195,15 +8195,15 @@
         </p:nvSpPr>
         <p:spPr>
           <a:xfrm>
-            <a:off x="2913309" y="773337"/>
-            <a:ext cx="13564423" cy="1102866"/>
+            <a:off x="3124530" y="701150"/>
+            <a:ext cx="10269290" cy="2205732"/>
           </a:xfrm>
           <a:prstGeom prst="rect">
             <a:avLst/>
           </a:prstGeom>
         </p:spPr>
         <p:txBody>
-          <a:bodyPr lIns="0" tIns="0" rIns="0" bIns="0" rtlCol="0" anchor="t">
+          <a:bodyPr wrap="square" lIns="0" tIns="0" rIns="0" bIns="0" rtlCol="0" anchor="t">
             <a:spAutoFit/>
           </a:bodyPr>
           <a:lstStyle/>
@@ -8236,8 +8236,8 @@
         </p:nvSpPr>
         <p:spPr>
           <a:xfrm>
-            <a:off x="770454" y="4107640"/>
-            <a:ext cx="8118707" cy="4928722"/>
+            <a:off x="770454" y="4709710"/>
+            <a:ext cx="8090477" cy="5482719"/>
           </a:xfrm>
           <a:prstGeom prst="rect">
             <a:avLst/>
@@ -8352,26 +8352,6 @@
               </a:rPr>
               <a:t>Proper certificate validation helps prevent MITM attacks.</a:t>
             </a:r>
-          </a:p>
-          <a:p>
-            <a:pPr marL="259080" lvl="1" algn="r">
-              <a:lnSpc>
-                <a:spcPct val="150000"/>
-              </a:lnSpc>
-            </a:pPr>
-            <a:r>
-              <a:rPr lang="en-KR" sz="2400" dirty="0"/>
-              <a:t>(Tucker, 2024; Rescorla, 2018)</a:t>
-            </a:r>
-            <a:endParaRPr lang="en-US" sz="2400" dirty="0">
-              <a:solidFill>
-                <a:srgbClr val="000000"/>
-              </a:solidFill>
-              <a:latin typeface="Candara" panose="020E0502030303020204" pitchFamily="34" charset="0"/>
-              <a:ea typeface="Aileron"/>
-              <a:cs typeface="Aileron"/>
-              <a:sym typeface="Aileron"/>
-            </a:endParaRPr>
           </a:p>
           <a:p>
             <a:pPr marL="518160" lvl="1" indent="-259080">
@@ -8391,6 +8371,44 @@
               <a:sym typeface="Aileron"/>
             </a:endParaRPr>
           </a:p>
+          <a:p>
+            <a:pPr marL="259080" lvl="1" algn="r">
+              <a:lnSpc>
+                <a:spcPct val="150000"/>
+              </a:lnSpc>
+            </a:pPr>
+            <a:r>
+              <a:rPr lang="en-KR" sz="2400" dirty="0"/>
+              <a:t>(Tucker, 2024; Rescorla, 2018)</a:t>
+            </a:r>
+            <a:endParaRPr lang="en-US" sz="2400" dirty="0">
+              <a:solidFill>
+                <a:srgbClr val="000000"/>
+              </a:solidFill>
+              <a:latin typeface="Candara" panose="020E0502030303020204" pitchFamily="34" charset="0"/>
+              <a:ea typeface="Aileron"/>
+              <a:cs typeface="Aileron"/>
+              <a:sym typeface="Aileron"/>
+            </a:endParaRPr>
+          </a:p>
+          <a:p>
+            <a:pPr marL="518160" lvl="1" indent="-259080">
+              <a:lnSpc>
+                <a:spcPct val="150000"/>
+              </a:lnSpc>
+              <a:buFont typeface="Arial"/>
+              <a:buChar char="•"/>
+            </a:pPr>
+            <a:endParaRPr lang="en-US" sz="2400" dirty="0">
+              <a:solidFill>
+                <a:srgbClr val="000000"/>
+              </a:solidFill>
+              <a:latin typeface="Candara" panose="020E0502030303020204" pitchFamily="34" charset="0"/>
+              <a:ea typeface="Aileron"/>
+              <a:cs typeface="Aileron"/>
+              <a:sym typeface="Aileron"/>
+            </a:endParaRPr>
+          </a:p>
         </p:txBody>
       </p:sp>
       <p:sp>
@@ -8401,15 +8419,15 @@
         </p:nvSpPr>
         <p:spPr>
           <a:xfrm>
-            <a:off x="4590636" y="1461723"/>
-            <a:ext cx="10209770" cy="992579"/>
+            <a:off x="3777880" y="2733898"/>
+            <a:ext cx="8962589" cy="961802"/>
           </a:xfrm>
           <a:prstGeom prst="rect">
             <a:avLst/>
           </a:prstGeom>
         </p:spPr>
         <p:txBody>
-          <a:bodyPr lIns="0" tIns="0" rIns="0" bIns="0" rtlCol="0" anchor="t">
+          <a:bodyPr wrap="square" lIns="0" tIns="0" rIns="0" bIns="0" rtlCol="0" anchor="t">
             <a:spAutoFit/>
           </a:bodyPr>
           <a:lstStyle/>
@@ -8459,8 +8477,8 @@
         </p:blipFill>
         <p:spPr>
           <a:xfrm>
-            <a:off x="9821616" y="3710421"/>
-            <a:ext cx="9521488" cy="4999939"/>
+            <a:off x="9109158" y="4447926"/>
+            <a:ext cx="8090477" cy="4248484"/>
           </a:xfrm>
           <a:prstGeom prst="rect">
             <a:avLst/>
@@ -8488,8 +8506,8 @@
         </p:nvSpPr>
         <p:spPr>
           <a:xfrm>
-            <a:off x="10093851" y="8848492"/>
-            <a:ext cx="2936349" cy="369332"/>
+            <a:off x="9066181" y="9009611"/>
+            <a:ext cx="2577657" cy="738664"/>
           </a:xfrm>
           <a:prstGeom prst="rect">
             <a:avLst/>
@@ -8566,8 +8584,8 @@
         </p:nvSpPr>
         <p:spPr>
           <a:xfrm rot="-5400000">
-            <a:off x="4557186" y="-5988665"/>
-            <a:ext cx="11718479" cy="20832852"/>
+            <a:off x="4000500" y="-4000501"/>
+            <a:ext cx="10287001" cy="18288002"/>
           </a:xfrm>
           <a:custGeom>
             <a:avLst/>
@@ -8625,8 +8643,8 @@
         </p:nvSpPr>
         <p:spPr>
           <a:xfrm flipV="1">
-            <a:off x="519025" y="396902"/>
-            <a:ext cx="2359274" cy="2359274"/>
+            <a:off x="519025" y="685100"/>
+            <a:ext cx="2071075" cy="2071075"/>
           </a:xfrm>
           <a:custGeom>
             <a:avLst/>
@@ -8684,8 +8702,8 @@
         </p:nvSpPr>
         <p:spPr>
           <a:xfrm flipH="1">
-            <a:off x="15486600" y="7366014"/>
-            <a:ext cx="2359274" cy="2359274"/>
+            <a:off x="15486600" y="7654212"/>
+            <a:ext cx="2071075" cy="2071075"/>
           </a:xfrm>
           <a:custGeom>
             <a:avLst/>
@@ -8743,8 +8761,8 @@
         </p:nvSpPr>
         <p:spPr>
           <a:xfrm>
-            <a:off x="15486600" y="396902"/>
-            <a:ext cx="4114800" cy="4114800"/>
+            <a:off x="14784030" y="-62821"/>
+            <a:ext cx="3612154" cy="3612154"/>
           </a:xfrm>
           <a:custGeom>
             <a:avLst/>
@@ -8803,8 +8821,8 @@
         </p:nvSpPr>
         <p:spPr>
           <a:xfrm>
-            <a:off x="57095" y="7366014"/>
-            <a:ext cx="2693378" cy="2693378"/>
+            <a:off x="57095" y="7695024"/>
+            <a:ext cx="2364367" cy="2364367"/>
           </a:xfrm>
           <a:custGeom>
             <a:avLst/>
@@ -8863,8 +8881,8 @@
         </p:nvSpPr>
         <p:spPr>
           <a:xfrm>
-            <a:off x="1175729" y="2749834"/>
-            <a:ext cx="7038181" cy="7038181"/>
+            <a:off x="374773" y="3609587"/>
+            <a:ext cx="6178427" cy="6178428"/>
           </a:xfrm>
           <a:custGeom>
             <a:avLst/>
@@ -8916,15 +8934,15 @@
         </p:nvSpPr>
         <p:spPr>
           <a:xfrm>
-            <a:off x="2890656" y="885474"/>
-            <a:ext cx="13548977" cy="1102866"/>
+            <a:off x="2574163" y="256838"/>
+            <a:ext cx="10317559" cy="2205732"/>
           </a:xfrm>
           <a:prstGeom prst="rect">
             <a:avLst/>
           </a:prstGeom>
         </p:spPr>
         <p:txBody>
-          <a:bodyPr lIns="0" tIns="0" rIns="0" bIns="0" rtlCol="0" anchor="t">
+          <a:bodyPr wrap="square" lIns="0" tIns="0" rIns="0" bIns="0" rtlCol="0" anchor="t">
             <a:spAutoFit/>
           </a:bodyPr>
           <a:lstStyle/>
@@ -8957,8 +8975,8 @@
         </p:nvSpPr>
         <p:spPr>
           <a:xfrm>
-            <a:off x="6041115" y="1592639"/>
-            <a:ext cx="8750620" cy="992579"/>
+            <a:off x="4179008" y="2055933"/>
+            <a:ext cx="7681682" cy="961802"/>
           </a:xfrm>
           <a:prstGeom prst="rect">
             <a:avLst/>
@@ -9007,8 +9025,8 @@
         </p:nvGrpSpPr>
         <p:grpSpPr>
           <a:xfrm>
-            <a:off x="8534400" y="2719191"/>
-            <a:ext cx="5720748" cy="3580546"/>
+            <a:off x="7010400" y="3619449"/>
+            <a:ext cx="5021926" cy="3143162"/>
             <a:chOff x="0" y="-38100"/>
             <a:chExt cx="1723392" cy="984671"/>
           </a:xfrm>
@@ -9156,8 +9174,8 @@
         </p:nvSpPr>
         <p:spPr>
           <a:xfrm>
-            <a:off x="8694974" y="3128927"/>
-            <a:ext cx="5426638" cy="410369"/>
+            <a:off x="7135047" y="3946399"/>
+            <a:ext cx="4763743" cy="410369"/>
           </a:xfrm>
           <a:prstGeom prst="rect">
             <a:avLst/>
@@ -9203,8 +9221,8 @@
         </p:nvSpPr>
         <p:spPr>
           <a:xfrm>
-            <a:off x="8653380" y="3673269"/>
-            <a:ext cx="5340470" cy="2158732"/>
+            <a:off x="7129380" y="4399843"/>
+            <a:ext cx="4688101" cy="2158732"/>
           </a:xfrm>
           <a:prstGeom prst="rect">
             <a:avLst/>
@@ -9279,8 +9297,8 @@
         </p:nvGrpSpPr>
         <p:grpSpPr>
           <a:xfrm>
-            <a:off x="14415722" y="2698149"/>
-            <a:ext cx="5720748" cy="3580546"/>
+            <a:off x="12891722" y="3598407"/>
+            <a:ext cx="5021926" cy="3143162"/>
             <a:chOff x="0" y="-38100"/>
             <a:chExt cx="1723392" cy="984671"/>
           </a:xfrm>
@@ -9428,8 +9446,8 @@
         </p:nvSpPr>
         <p:spPr>
           <a:xfrm>
-            <a:off x="14576296" y="3107885"/>
-            <a:ext cx="5426638" cy="410369"/>
+            <a:off x="13016369" y="3925357"/>
+            <a:ext cx="4763743" cy="410369"/>
           </a:xfrm>
           <a:prstGeom prst="rect">
             <a:avLst/>
@@ -9475,8 +9493,8 @@
         </p:nvSpPr>
         <p:spPr>
           <a:xfrm>
-            <a:off x="14534702" y="3673269"/>
-            <a:ext cx="5340470" cy="2158732"/>
+            <a:off x="13010702" y="4399843"/>
+            <a:ext cx="4688101" cy="2158732"/>
           </a:xfrm>
           <a:prstGeom prst="rect">
             <a:avLst/>
@@ -9551,8 +9569,8 @@
         </p:nvGrpSpPr>
         <p:grpSpPr>
           <a:xfrm>
-            <a:off x="8534400" y="6567463"/>
-            <a:ext cx="11602070" cy="2995637"/>
+            <a:off x="7010400" y="6800932"/>
+            <a:ext cx="10902827" cy="2791890"/>
             <a:chOff x="0" y="-38100"/>
             <a:chExt cx="1723392" cy="984671"/>
           </a:xfrm>
@@ -9700,8 +9718,8 @@
         </p:nvSpPr>
         <p:spPr>
           <a:xfrm>
-            <a:off x="9919922" y="6842677"/>
-            <a:ext cx="8831026" cy="410369"/>
+            <a:off x="8935264" y="6989212"/>
+            <a:ext cx="7752266" cy="410369"/>
           </a:xfrm>
           <a:prstGeom prst="rect">
             <a:avLst/>
@@ -9747,8 +9765,8 @@
         </p:nvSpPr>
         <p:spPr>
           <a:xfrm>
-            <a:off x="8653380" y="7154327"/>
-            <a:ext cx="11221792" cy="2158732"/>
+            <a:off x="7706688" y="7285562"/>
+            <a:ext cx="9850986" cy="2158732"/>
           </a:xfrm>
           <a:prstGeom prst="rect">
             <a:avLst/>
@@ -9871,8 +9889,8 @@
         </p:nvSpPr>
         <p:spPr>
           <a:xfrm>
-            <a:off x="5873498" y="9603349"/>
-            <a:ext cx="2560257" cy="369332"/>
+            <a:off x="3228113" y="9557594"/>
+            <a:ext cx="2247507" cy="369332"/>
           </a:xfrm>
           <a:prstGeom prst="rect">
             <a:avLst/>
@@ -9922,8 +9940,8 @@
         </p:nvSpPr>
         <p:spPr>
           <a:xfrm>
-            <a:off x="14282187" y="9620756"/>
-            <a:ext cx="5720747" cy="496739"/>
+            <a:off x="12461813" y="9645064"/>
+            <a:ext cx="5021925" cy="496739"/>
           </a:xfrm>
           <a:prstGeom prst="rect">
             <a:avLst/>
@@ -10015,8 +10033,8 @@
         </p:nvSpPr>
         <p:spPr>
           <a:xfrm rot="-5400000">
-            <a:off x="4557186" y="-5738286"/>
-            <a:ext cx="11718479" cy="20832852"/>
+            <a:off x="3875311" y="-3875312"/>
+            <a:ext cx="10537380" cy="18288002"/>
           </a:xfrm>
           <a:custGeom>
             <a:avLst/>
@@ -10074,8 +10092,8 @@
         </p:nvSpPr>
         <p:spPr>
           <a:xfrm flipV="1">
-            <a:off x="519025" y="396902"/>
-            <a:ext cx="2359274" cy="2359274"/>
+            <a:off x="519025" y="634692"/>
+            <a:ext cx="2071075" cy="2121484"/>
           </a:xfrm>
           <a:custGeom>
             <a:avLst/>
@@ -10133,8 +10151,8 @@
         </p:nvSpPr>
         <p:spPr>
           <a:xfrm flipH="1">
-            <a:off x="15486600" y="7366014"/>
-            <a:ext cx="2359274" cy="2359274"/>
+            <a:off x="15486600" y="7603804"/>
+            <a:ext cx="2071075" cy="2121484"/>
           </a:xfrm>
           <a:custGeom>
             <a:avLst/>
@@ -10192,8 +10210,8 @@
         </p:nvSpPr>
         <p:spPr>
           <a:xfrm>
-            <a:off x="15486600" y="396902"/>
-            <a:ext cx="4114800" cy="4114800"/>
+            <a:off x="14718536" y="-44175"/>
+            <a:ext cx="3612154" cy="3700072"/>
           </a:xfrm>
           <a:custGeom>
             <a:avLst/>
@@ -10252,8 +10270,8 @@
         </p:nvSpPr>
         <p:spPr>
           <a:xfrm>
-            <a:off x="57095" y="7366014"/>
-            <a:ext cx="2693378" cy="2693378"/>
+            <a:off x="57095" y="7637478"/>
+            <a:ext cx="2364367" cy="2421914"/>
           </a:xfrm>
           <a:custGeom>
             <a:avLst/>
@@ -10312,15 +10330,15 @@
         </p:nvSpPr>
         <p:spPr>
           <a:xfrm>
-            <a:off x="2750473" y="227608"/>
-            <a:ext cx="13798211" cy="1102866"/>
+            <a:off x="2023537" y="510141"/>
+            <a:ext cx="12112681" cy="2205732"/>
           </a:xfrm>
           <a:prstGeom prst="rect">
             <a:avLst/>
           </a:prstGeom>
         </p:spPr>
         <p:txBody>
-          <a:bodyPr lIns="0" tIns="0" rIns="0" bIns="0" rtlCol="0" anchor="t">
+          <a:bodyPr wrap="square" lIns="0" tIns="0" rIns="0" bIns="0" rtlCol="0" anchor="t">
             <a:spAutoFit/>
           </a:bodyPr>
           <a:lstStyle/>
@@ -10367,8 +10385,8 @@
         </p:blipFill>
         <p:spPr>
           <a:xfrm>
-            <a:off x="519026" y="2609959"/>
-            <a:ext cx="15036542" cy="6343541"/>
+            <a:off x="285341" y="3878227"/>
+            <a:ext cx="12112682" cy="5685767"/>
           </a:xfrm>
           <a:prstGeom prst="rect">
             <a:avLst/>
@@ -10396,8 +10414,8 @@
         </p:nvGrpSpPr>
         <p:grpSpPr>
           <a:xfrm>
-            <a:off x="15746908" y="2279414"/>
-            <a:ext cx="4829289" cy="6674086"/>
+            <a:off x="12649200" y="3527504"/>
+            <a:ext cx="5411263" cy="5996187"/>
             <a:chOff x="0" y="-38100"/>
             <a:chExt cx="1723392" cy="984671"/>
           </a:xfrm>
@@ -10545,8 +10563,8 @@
         </p:nvSpPr>
         <p:spPr>
           <a:xfrm>
-            <a:off x="15772848" y="2708094"/>
-            <a:ext cx="4638521" cy="6278642"/>
+            <a:off x="12573000" y="3916328"/>
+            <a:ext cx="5411263" cy="6463308"/>
           </a:xfrm>
           <a:prstGeom prst="rect">
             <a:avLst/>
@@ -10678,6 +10696,25 @@
             </a:r>
           </a:p>
           <a:p>
+            <a:pPr marL="259080" lvl="1">
+              <a:lnSpc>
+                <a:spcPct val="150000"/>
+              </a:lnSpc>
+              <a:spcBef>
+                <a:spcPct val="0"/>
+              </a:spcBef>
+            </a:pPr>
+            <a:endParaRPr lang="en-US" sz="2400" dirty="0">
+              <a:solidFill>
+                <a:srgbClr val="000000"/>
+              </a:solidFill>
+              <a:latin typeface="Candara" panose="020E0502030303020204" pitchFamily="34" charset="0"/>
+              <a:ea typeface="Open Sans"/>
+              <a:cs typeface="Open Sans"/>
+              <a:sym typeface="Open Sans"/>
+            </a:endParaRPr>
+          </a:p>
+          <a:p>
             <a:pPr marL="259080" lvl="1" algn="r">
               <a:spcBef>
                 <a:spcPct val="0"/>
@@ -10712,8 +10749,8 @@
         </p:nvSpPr>
         <p:spPr>
           <a:xfrm>
-            <a:off x="12649200" y="9098809"/>
-            <a:ext cx="3387887" cy="369332"/>
+            <a:off x="9753600" y="9969254"/>
+            <a:ext cx="2974037" cy="369332"/>
           </a:xfrm>
           <a:prstGeom prst="rect">
             <a:avLst/>
@@ -10790,8 +10827,8 @@
         </p:nvSpPr>
         <p:spPr>
           <a:xfrm rot="-5400000">
-            <a:off x="4557186" y="-5904724"/>
-            <a:ext cx="11718479" cy="20832852"/>
+            <a:off x="3958530" y="-3958531"/>
+            <a:ext cx="10370942" cy="18288002"/>
           </a:xfrm>
           <a:custGeom>
             <a:avLst/>
@@ -10849,8 +10886,8 @@
         </p:nvSpPr>
         <p:spPr>
           <a:xfrm flipV="1">
-            <a:off x="519025" y="396902"/>
-            <a:ext cx="2359274" cy="2359274"/>
+            <a:off x="519025" y="668200"/>
+            <a:ext cx="2071075" cy="2087975"/>
           </a:xfrm>
           <a:custGeom>
             <a:avLst/>
@@ -10908,8 +10945,8 @@
         </p:nvSpPr>
         <p:spPr>
           <a:xfrm flipH="1">
-            <a:off x="15486600" y="7366014"/>
-            <a:ext cx="2359274" cy="2359274"/>
+            <a:off x="15486600" y="7637312"/>
+            <a:ext cx="2071075" cy="2087975"/>
           </a:xfrm>
           <a:custGeom>
             <a:avLst/>
@@ -10967,8 +11004,8 @@
         </p:nvSpPr>
         <p:spPr>
           <a:xfrm>
-            <a:off x="15486600" y="396902"/>
-            <a:ext cx="4114800" cy="4114800"/>
+            <a:off x="14716060" y="-1"/>
+            <a:ext cx="3612154" cy="3641629"/>
           </a:xfrm>
           <a:custGeom>
             <a:avLst/>
@@ -11027,8 +11064,8 @@
         </p:nvSpPr>
         <p:spPr>
           <a:xfrm>
-            <a:off x="57095" y="7366014"/>
-            <a:ext cx="2693378" cy="2693378"/>
+            <a:off x="57095" y="7675732"/>
+            <a:ext cx="2364367" cy="2383660"/>
           </a:xfrm>
           <a:custGeom>
             <a:avLst/>
@@ -11087,15 +11124,15 @@
         </p:nvSpPr>
         <p:spPr>
           <a:xfrm>
-            <a:off x="7616363" y="450697"/>
-            <a:ext cx="5071252" cy="1284605"/>
+            <a:off x="6424633" y="1269380"/>
+            <a:ext cx="5438733" cy="1102866"/>
           </a:xfrm>
           <a:prstGeom prst="rect">
             <a:avLst/>
           </a:prstGeom>
         </p:spPr>
         <p:txBody>
-          <a:bodyPr lIns="0" tIns="0" rIns="0" bIns="0" rtlCol="0" anchor="t">
+          <a:bodyPr wrap="square" lIns="0" tIns="0" rIns="0" bIns="0" rtlCol="0" anchor="t">
             <a:spAutoFit/>
           </a:bodyPr>
           <a:lstStyle/>
@@ -11142,8 +11179,8 @@
         </p:blipFill>
         <p:spPr>
           <a:xfrm>
-            <a:off x="2310876" y="1997086"/>
-            <a:ext cx="16211098" cy="7226803"/>
+            <a:off x="1970527" y="3135606"/>
+            <a:ext cx="14346944" cy="6395775"/>
           </a:xfrm>
           <a:prstGeom prst="rect">
             <a:avLst/>
@@ -11171,8 +11208,8 @@
         </p:nvSpPr>
         <p:spPr>
           <a:xfrm>
-            <a:off x="2310876" y="9301007"/>
-            <a:ext cx="2560257" cy="369332"/>
+            <a:off x="2421462" y="9570317"/>
+            <a:ext cx="2870724" cy="369332"/>
           </a:xfrm>
           <a:prstGeom prst="rect">
             <a:avLst/>
@@ -11241,10 +11278,10 @@
       </p:grpSpPr>
       <p:sp>
         <p:nvSpPr>
-          <p:cNvPr id="2" name="Freeform 2">
+          <p:cNvPr id="3" name="Freeform 3">
             <a:extLst>
               <a:ext uri="{FF2B5EF4-FFF2-40B4-BE49-F238E27FC236}">
-                <a16:creationId xmlns:a16="http://schemas.microsoft.com/office/drawing/2014/main" id="{AC8D73F4-2FAE-5DEC-4F1D-21D30F2AE596}"/>
+                <a16:creationId xmlns:a16="http://schemas.microsoft.com/office/drawing/2014/main" id="{B2E85564-9014-6A14-E22F-384E59253ABE}"/>
               </a:ext>
             </a:extLst>
           </p:cNvPr>
@@ -11252,8 +11289,8 @@
           <p:nvPr/>
         </p:nvSpPr>
         <p:spPr>
-          <a:xfrm flipV="1">
-            <a:off x="519025" y="396902"/>
+          <a:xfrm flipH="1">
+            <a:off x="15486600" y="7366014"/>
             <a:ext cx="2359274" cy="2359274"/>
           </a:xfrm>
           <a:custGeom>
@@ -11265,19 +11302,19 @@
             <a:pathLst>
               <a:path w="2359274" h="2359274">
                 <a:moveTo>
+                  <a:pt x="2359274" y="0"/>
+                </a:moveTo>
+                <a:lnTo>
+                  <a:pt x="0" y="0"/>
+                </a:lnTo>
+                <a:lnTo>
                   <a:pt x="0" y="2359274"/>
-                </a:moveTo>
+                </a:lnTo>
                 <a:lnTo>
                   <a:pt x="2359274" y="2359274"/>
                 </a:lnTo>
                 <a:lnTo>
                   <a:pt x="2359274" y="0"/>
-                </a:lnTo>
-                <a:lnTo>
-                  <a:pt x="0" y="0"/>
-                </a:lnTo>
-                <a:lnTo>
-                  <a:pt x="0" y="2359274"/>
                 </a:lnTo>
                 <a:close/>
               </a:path>
@@ -11304,6 +11341,137 @@
           </a:p>
         </p:txBody>
       </p:sp>
+      <p:sp>
+        <p:nvSpPr>
+          <p:cNvPr id="4" name="Freeform 4">
+            <a:extLst>
+              <a:ext uri="{FF2B5EF4-FFF2-40B4-BE49-F238E27FC236}">
+                <a16:creationId xmlns:a16="http://schemas.microsoft.com/office/drawing/2014/main" id="{1EA76D82-813C-24B0-10C6-A5C4C0B4343D}"/>
+              </a:ext>
+            </a:extLst>
+          </p:cNvPr>
+          <p:cNvSpPr/>
+          <p:nvPr/>
+        </p:nvSpPr>
+        <p:spPr>
+          <a:xfrm>
+            <a:off x="14209837" y="-82907"/>
+            <a:ext cx="4114800" cy="4114800"/>
+          </a:xfrm>
+          <a:custGeom>
+            <a:avLst/>
+            <a:gdLst/>
+            <a:ahLst/>
+            <a:cxnLst/>
+            <a:rect l="l" t="t" r="r" b="b"/>
+            <a:pathLst>
+              <a:path w="4114800" h="4114800">
+                <a:moveTo>
+                  <a:pt x="0" y="0"/>
+                </a:moveTo>
+                <a:lnTo>
+                  <a:pt x="4114800" y="0"/>
+                </a:lnTo>
+                <a:lnTo>
+                  <a:pt x="4114800" y="4114800"/>
+                </a:lnTo>
+                <a:lnTo>
+                  <a:pt x="0" y="4114800"/>
+                </a:lnTo>
+                <a:lnTo>
+                  <a:pt x="0" y="0"/>
+                </a:lnTo>
+                <a:close/>
+              </a:path>
+            </a:pathLst>
+          </a:custGeom>
+          <a:blipFill>
+            <a:blip>
+              <a:alphaModFix amt="24000"/>
+              <a:extLst>
+                <a:ext uri="{96DAC541-7B7A-43D3-8B79-37D633B846F1}">
+                  <asvg:svgBlip xmlns:asvg="http://schemas.microsoft.com/office/drawing/2016/SVG/main" r:embed="rId3"/>
+                </a:ext>
+              </a:extLst>
+            </a:blip>
+            <a:stretch>
+              <a:fillRect/>
+            </a:stretch>
+          </a:blipFill>
+        </p:spPr>
+        <p:txBody>
+          <a:bodyPr/>
+          <a:lstStyle/>
+          <a:p>
+            <a:endParaRPr lang="en-CA"/>
+          </a:p>
+        </p:txBody>
+      </p:sp>
+      <p:sp>
+        <p:nvSpPr>
+          <p:cNvPr id="2" name="Freeform 2">
+            <a:extLst>
+              <a:ext uri="{FF2B5EF4-FFF2-40B4-BE49-F238E27FC236}">
+                <a16:creationId xmlns:a16="http://schemas.microsoft.com/office/drawing/2014/main" id="{AC8D73F4-2FAE-5DEC-4F1D-21D30F2AE596}"/>
+              </a:ext>
+            </a:extLst>
+          </p:cNvPr>
+          <p:cNvSpPr/>
+          <p:nvPr/>
+        </p:nvSpPr>
+        <p:spPr>
+          <a:xfrm flipV="1">
+            <a:off x="519025" y="396902"/>
+            <a:ext cx="2359274" cy="2359274"/>
+          </a:xfrm>
+          <a:custGeom>
+            <a:avLst/>
+            <a:gdLst/>
+            <a:ahLst/>
+            <a:cxnLst/>
+            <a:rect l="l" t="t" r="r" b="b"/>
+            <a:pathLst>
+              <a:path w="2359274" h="2359274">
+                <a:moveTo>
+                  <a:pt x="0" y="2359274"/>
+                </a:moveTo>
+                <a:lnTo>
+                  <a:pt x="2359274" y="2359274"/>
+                </a:lnTo>
+                <a:lnTo>
+                  <a:pt x="2359274" y="0"/>
+                </a:lnTo>
+                <a:lnTo>
+                  <a:pt x="0" y="0"/>
+                </a:lnTo>
+                <a:lnTo>
+                  <a:pt x="0" y="2359274"/>
+                </a:lnTo>
+                <a:close/>
+              </a:path>
+            </a:pathLst>
+          </a:custGeom>
+          <a:blipFill>
+            <a:blip>
+              <a:extLst>
+                <a:ext uri="{96DAC541-7B7A-43D3-8B79-37D633B846F1}">
+                  <asvg:svgBlip xmlns:asvg="http://schemas.microsoft.com/office/drawing/2016/SVG/main" r:embed="rId2"/>
+                </a:ext>
+              </a:extLst>
+            </a:blip>
+            <a:stretch>
+              <a:fillRect/>
+            </a:stretch>
+          </a:blipFill>
+        </p:spPr>
+        <p:txBody>
+          <a:bodyPr/>
+          <a:lstStyle/>
+          <a:p>
+            <a:endParaRPr lang="en-CA"/>
+          </a:p>
+        </p:txBody>
+      </p:sp>
       <p:grpSp>
         <p:nvGrpSpPr>
           <p:cNvPr id="8" name="Group 3">
@@ -11318,8 +11486,8 @@
         </p:nvGrpSpPr>
         <p:grpSpPr>
           <a:xfrm>
-            <a:off x="223495" y="1866900"/>
-            <a:ext cx="17841010" cy="8191500"/>
+            <a:off x="223495" y="1943100"/>
+            <a:ext cx="17841010" cy="7467600"/>
             <a:chOff x="0" y="-38100"/>
             <a:chExt cx="1723392" cy="984671"/>
           </a:xfrm>
@@ -11453,137 +11621,6 @@
           </p:txBody>
         </p:sp>
       </p:grpSp>
-      <p:sp>
-        <p:nvSpPr>
-          <p:cNvPr id="3" name="Freeform 3">
-            <a:extLst>
-              <a:ext uri="{FF2B5EF4-FFF2-40B4-BE49-F238E27FC236}">
-                <a16:creationId xmlns:a16="http://schemas.microsoft.com/office/drawing/2014/main" id="{B2E85564-9014-6A14-E22F-384E59253ABE}"/>
-              </a:ext>
-            </a:extLst>
-          </p:cNvPr>
-          <p:cNvSpPr/>
-          <p:nvPr/>
-        </p:nvSpPr>
-        <p:spPr>
-          <a:xfrm flipH="1">
-            <a:off x="15486600" y="7366014"/>
-            <a:ext cx="2359274" cy="2359274"/>
-          </a:xfrm>
-          <a:custGeom>
-            <a:avLst/>
-            <a:gdLst/>
-            <a:ahLst/>
-            <a:cxnLst/>
-            <a:rect l="l" t="t" r="r" b="b"/>
-            <a:pathLst>
-              <a:path w="2359274" h="2359274">
-                <a:moveTo>
-                  <a:pt x="2359274" y="0"/>
-                </a:moveTo>
-                <a:lnTo>
-                  <a:pt x="0" y="0"/>
-                </a:lnTo>
-                <a:lnTo>
-                  <a:pt x="0" y="2359274"/>
-                </a:lnTo>
-                <a:lnTo>
-                  <a:pt x="2359274" y="2359274"/>
-                </a:lnTo>
-                <a:lnTo>
-                  <a:pt x="2359274" y="0"/>
-                </a:lnTo>
-                <a:close/>
-              </a:path>
-            </a:pathLst>
-          </a:custGeom>
-          <a:blipFill>
-            <a:blip>
-              <a:extLst>
-                <a:ext uri="{96DAC541-7B7A-43D3-8B79-37D633B846F1}">
-                  <asvg:svgBlip xmlns:asvg="http://schemas.microsoft.com/office/drawing/2016/SVG/main" r:embed="rId2"/>
-                </a:ext>
-              </a:extLst>
-            </a:blip>
-            <a:stretch>
-              <a:fillRect/>
-            </a:stretch>
-          </a:blipFill>
-        </p:spPr>
-        <p:txBody>
-          <a:bodyPr/>
-          <a:lstStyle/>
-          <a:p>
-            <a:endParaRPr lang="en-CA"/>
-          </a:p>
-        </p:txBody>
-      </p:sp>
-      <p:sp>
-        <p:nvSpPr>
-          <p:cNvPr id="4" name="Freeform 4">
-            <a:extLst>
-              <a:ext uri="{FF2B5EF4-FFF2-40B4-BE49-F238E27FC236}">
-                <a16:creationId xmlns:a16="http://schemas.microsoft.com/office/drawing/2014/main" id="{1EA76D82-813C-24B0-10C6-A5C4C0B4343D}"/>
-              </a:ext>
-            </a:extLst>
-          </p:cNvPr>
-          <p:cNvSpPr/>
-          <p:nvPr/>
-        </p:nvSpPr>
-        <p:spPr>
-          <a:xfrm>
-            <a:off x="14961438" y="-869666"/>
-            <a:ext cx="4114800" cy="4114800"/>
-          </a:xfrm>
-          <a:custGeom>
-            <a:avLst/>
-            <a:gdLst/>
-            <a:ahLst/>
-            <a:cxnLst/>
-            <a:rect l="l" t="t" r="r" b="b"/>
-            <a:pathLst>
-              <a:path w="4114800" h="4114800">
-                <a:moveTo>
-                  <a:pt x="0" y="0"/>
-                </a:moveTo>
-                <a:lnTo>
-                  <a:pt x="4114800" y="0"/>
-                </a:lnTo>
-                <a:lnTo>
-                  <a:pt x="4114800" y="4114800"/>
-                </a:lnTo>
-                <a:lnTo>
-                  <a:pt x="0" y="4114800"/>
-                </a:lnTo>
-                <a:lnTo>
-                  <a:pt x="0" y="0"/>
-                </a:lnTo>
-                <a:close/>
-              </a:path>
-            </a:pathLst>
-          </a:custGeom>
-          <a:blipFill>
-            <a:blip>
-              <a:alphaModFix amt="24000"/>
-              <a:extLst>
-                <a:ext uri="{96DAC541-7B7A-43D3-8B79-37D633B846F1}">
-                  <asvg:svgBlip xmlns:asvg="http://schemas.microsoft.com/office/drawing/2016/SVG/main" r:embed="rId3"/>
-                </a:ext>
-              </a:extLst>
-            </a:blip>
-            <a:stretch>
-              <a:fillRect/>
-            </a:stretch>
-          </a:blipFill>
-        </p:spPr>
-        <p:txBody>
-          <a:bodyPr/>
-          <a:lstStyle/>
-          <a:p>
-            <a:endParaRPr lang="en-CA"/>
-          </a:p>
-        </p:txBody>
-      </p:sp>
       <p:sp>
         <p:nvSpPr>
           <p:cNvPr id="5" name="TextBox 5">

</xml_diff>

<commit_message>
Edited alignment and format
Edited alignment and format
</commit_message>
<xml_diff>
--- a/CEP146NBB_Project1.pptx
+++ b/CEP146NBB_Project1.pptx
@@ -23,16 +23,16 @@
   <p:notesSz cx="6858000" cy="9144000"/>
   <p:embeddedFontLst>
     <p:embeddedFont>
-      <p:font typeface="Alegreya Sans SC" panose="020B0604020202020204" charset="0"/>
+      <p:font typeface="Alegreya Sans SC" pitchFamily="2" charset="0"/>
       <p:regular r:id="rId13"/>
     </p:embeddedFont>
     <p:embeddedFont>
-      <p:font typeface="Alegreya Sans SC Bold" panose="020B0604020202020204" charset="0"/>
+      <p:font typeface="Alegreya Sans SC Bold" pitchFamily="2" charset="0"/>
       <p:regular r:id="rId14"/>
       <p:bold r:id="rId15"/>
     </p:embeddedFont>
     <p:embeddedFont>
-      <p:font typeface="Alegreya Sans SC Medium" panose="020B0604020202020204" charset="0"/>
+      <p:font typeface="Alegreya Sans SC Medium" pitchFamily="2" charset="0"/>
       <p:regular r:id="rId16"/>
     </p:embeddedFont>
     <p:embeddedFont>
@@ -239,7 +239,7 @@
           <a:p>
             <a:fld id="{94BC2B38-408A-8647-991A-B19F79294DCD}" type="datetimeFigureOut">
               <a:rPr lang="en-KR" smtClean="0"/>
-              <a:t>10/18/2026</a:t>
+              <a:t>10/18/26</a:t>
             </a:fld>
             <a:endParaRPr lang="en-KR"/>
           </a:p>
@@ -572,7 +572,7 @@
           <a:p>
             <a:fld id="{FD023C59-4258-E346-BE1D-19B0B04B97D9}" type="slidenum">
               <a:rPr lang="en-KR" smtClean="0"/>
-              <a:t>5</a:t>
+              <a:t>3</a:t>
             </a:fld>
             <a:endParaRPr lang="en-KR"/>
           </a:p>
@@ -581,7 +581,7 @@
     </p:spTree>
     <p:extLst>
       <p:ext uri="{BB962C8B-B14F-4D97-AF65-F5344CB8AC3E}">
-        <p14:creationId xmlns:p14="http://schemas.microsoft.com/office/powerpoint/2010/main" val="3075139485"/>
+        <p14:creationId xmlns:p14="http://schemas.microsoft.com/office/powerpoint/2010/main" val="3931435016"/>
       </p:ext>
     </p:extLst>
   </p:cSld>
@@ -656,7 +656,7 @@
           <a:p>
             <a:fld id="{FD023C59-4258-E346-BE1D-19B0B04B97D9}" type="slidenum">
               <a:rPr lang="en-KR" smtClean="0"/>
-              <a:t>6</a:t>
+              <a:t>4</a:t>
             </a:fld>
             <a:endParaRPr lang="en-KR"/>
           </a:p>
@@ -665,7 +665,7 @@
     </p:spTree>
     <p:extLst>
       <p:ext uri="{BB962C8B-B14F-4D97-AF65-F5344CB8AC3E}">
-        <p14:creationId xmlns:p14="http://schemas.microsoft.com/office/powerpoint/2010/main" val="2215323873"/>
+        <p14:creationId xmlns:p14="http://schemas.microsoft.com/office/powerpoint/2010/main" val="4025847465"/>
       </p:ext>
     </p:extLst>
   </p:cSld>
@@ -740,6 +740,174 @@
           <a:p>
             <a:fld id="{FD023C59-4258-E346-BE1D-19B0B04B97D9}" type="slidenum">
               <a:rPr lang="en-KR" smtClean="0"/>
+              <a:t>5</a:t>
+            </a:fld>
+            <a:endParaRPr lang="en-KR"/>
+          </a:p>
+        </p:txBody>
+      </p:sp>
+    </p:spTree>
+    <p:extLst>
+      <p:ext uri="{BB962C8B-B14F-4D97-AF65-F5344CB8AC3E}">
+        <p14:creationId xmlns:p14="http://schemas.microsoft.com/office/powerpoint/2010/main" val="3075139485"/>
+      </p:ext>
+    </p:extLst>
+  </p:cSld>
+  <p:clrMapOvr>
+    <a:masterClrMapping/>
+  </p:clrMapOvr>
+</p:notes>
+</file>
+
+<file path=ppt/notesSlides/notesSlide4.xml><?xml version="1.0" encoding="utf-8"?>
+<p:notes xmlns:a="http://schemas.openxmlformats.org/drawingml/2006/main" xmlns:r="http://schemas.openxmlformats.org/officeDocument/2006/relationships" xmlns:p="http://schemas.openxmlformats.org/presentationml/2006/main">
+  <p:cSld>
+    <p:spTree>
+      <p:nvGrpSpPr>
+        <p:cNvPr id="1" name=""/>
+        <p:cNvGrpSpPr/>
+        <p:nvPr/>
+      </p:nvGrpSpPr>
+      <p:grpSpPr>
+        <a:xfrm>
+          <a:off x="0" y="0"/>
+          <a:ext cx="0" cy="0"/>
+          <a:chOff x="0" y="0"/>
+          <a:chExt cx="0" cy="0"/>
+        </a:xfrm>
+      </p:grpSpPr>
+      <p:sp>
+        <p:nvSpPr>
+          <p:cNvPr id="2" name="Slide Image Placeholder 1"/>
+          <p:cNvSpPr>
+            <a:spLocks noGrp="1" noRot="1" noChangeAspect="1"/>
+          </p:cNvSpPr>
+          <p:nvPr>
+            <p:ph type="sldImg"/>
+          </p:nvPr>
+        </p:nvSpPr>
+        <p:spPr/>
+      </p:sp>
+      <p:sp>
+        <p:nvSpPr>
+          <p:cNvPr id="3" name="Notes Placeholder 2"/>
+          <p:cNvSpPr>
+            <a:spLocks noGrp="1"/>
+          </p:cNvSpPr>
+          <p:nvPr>
+            <p:ph type="body" idx="1"/>
+          </p:nvPr>
+        </p:nvSpPr>
+        <p:spPr/>
+        <p:txBody>
+          <a:bodyPr/>
+          <a:lstStyle/>
+          <a:p>
+            <a:endParaRPr lang="en-KR" dirty="0"/>
+          </a:p>
+        </p:txBody>
+      </p:sp>
+      <p:sp>
+        <p:nvSpPr>
+          <p:cNvPr id="4" name="Slide Number Placeholder 3"/>
+          <p:cNvSpPr>
+            <a:spLocks noGrp="1"/>
+          </p:cNvSpPr>
+          <p:nvPr>
+            <p:ph type="sldNum" sz="quarter" idx="5"/>
+          </p:nvPr>
+        </p:nvSpPr>
+        <p:spPr/>
+        <p:txBody>
+          <a:bodyPr/>
+          <a:lstStyle/>
+          <a:p>
+            <a:fld id="{FD023C59-4258-E346-BE1D-19B0B04B97D9}" type="slidenum">
+              <a:rPr lang="en-KR" smtClean="0"/>
+              <a:t>6</a:t>
+            </a:fld>
+            <a:endParaRPr lang="en-KR"/>
+          </a:p>
+        </p:txBody>
+      </p:sp>
+    </p:spTree>
+    <p:extLst>
+      <p:ext uri="{BB962C8B-B14F-4D97-AF65-F5344CB8AC3E}">
+        <p14:creationId xmlns:p14="http://schemas.microsoft.com/office/powerpoint/2010/main" val="2215323873"/>
+      </p:ext>
+    </p:extLst>
+  </p:cSld>
+  <p:clrMapOvr>
+    <a:masterClrMapping/>
+  </p:clrMapOvr>
+</p:notes>
+</file>
+
+<file path=ppt/notesSlides/notesSlide5.xml><?xml version="1.0" encoding="utf-8"?>
+<p:notes xmlns:a="http://schemas.openxmlformats.org/drawingml/2006/main" xmlns:r="http://schemas.openxmlformats.org/officeDocument/2006/relationships" xmlns:p="http://schemas.openxmlformats.org/presentationml/2006/main">
+  <p:cSld>
+    <p:spTree>
+      <p:nvGrpSpPr>
+        <p:cNvPr id="1" name=""/>
+        <p:cNvGrpSpPr/>
+        <p:nvPr/>
+      </p:nvGrpSpPr>
+      <p:grpSpPr>
+        <a:xfrm>
+          <a:off x="0" y="0"/>
+          <a:ext cx="0" cy="0"/>
+          <a:chOff x="0" y="0"/>
+          <a:chExt cx="0" cy="0"/>
+        </a:xfrm>
+      </p:grpSpPr>
+      <p:sp>
+        <p:nvSpPr>
+          <p:cNvPr id="2" name="Slide Image Placeholder 1"/>
+          <p:cNvSpPr>
+            <a:spLocks noGrp="1" noRot="1" noChangeAspect="1"/>
+          </p:cNvSpPr>
+          <p:nvPr>
+            <p:ph type="sldImg"/>
+          </p:nvPr>
+        </p:nvSpPr>
+        <p:spPr/>
+      </p:sp>
+      <p:sp>
+        <p:nvSpPr>
+          <p:cNvPr id="3" name="Notes Placeholder 2"/>
+          <p:cNvSpPr>
+            <a:spLocks noGrp="1"/>
+          </p:cNvSpPr>
+          <p:nvPr>
+            <p:ph type="body" idx="1"/>
+          </p:nvPr>
+        </p:nvSpPr>
+        <p:spPr/>
+        <p:txBody>
+          <a:bodyPr/>
+          <a:lstStyle/>
+          <a:p>
+            <a:endParaRPr lang="en-KR" dirty="0"/>
+          </a:p>
+        </p:txBody>
+      </p:sp>
+      <p:sp>
+        <p:nvSpPr>
+          <p:cNvPr id="4" name="Slide Number Placeholder 3"/>
+          <p:cNvSpPr>
+            <a:spLocks noGrp="1"/>
+          </p:cNvSpPr>
+          <p:nvPr>
+            <p:ph type="sldNum" sz="quarter" idx="5"/>
+          </p:nvPr>
+        </p:nvSpPr>
+        <p:spPr/>
+        <p:txBody>
+          <a:bodyPr/>
+          <a:lstStyle/>
+          <a:p>
+            <a:fld id="{FD023C59-4258-E346-BE1D-19B0B04B97D9}" type="slidenum">
+              <a:rPr lang="en-KR" smtClean="0"/>
               <a:t>7</a:t>
             </a:fld>
             <a:endParaRPr lang="en-KR"/>
@@ -759,7 +927,7 @@
 </p:notes>
 </file>
 
-<file path=ppt/notesSlides/notesSlide4.xml><?xml version="1.0" encoding="utf-8"?>
+<file path=ppt/notesSlides/notesSlide6.xml><?xml version="1.0" encoding="utf-8"?>
 <p:notes xmlns:a="http://schemas.openxmlformats.org/drawingml/2006/main" xmlns:r="http://schemas.openxmlformats.org/officeDocument/2006/relationships" xmlns:p="http://schemas.openxmlformats.org/presentationml/2006/main">
   <p:cSld>
     <p:spTree>
@@ -1023,7 +1191,7 @@
             <a:fld id="{1D8BD707-D9CF-40AE-B4C6-C98DA3205C09}" type="datetimeFigureOut">
               <a:rPr lang="en-US" smtClean="0"/>
               <a:pPr/>
-              <a:t>10/18/2026</a:t>
+              <a:t>10/19/26</a:t>
             </a:fld>
             <a:endParaRPr lang="en-US"/>
           </a:p>
@@ -1188,7 +1356,7 @@
             <a:fld id="{1D8BD707-D9CF-40AE-B4C6-C98DA3205C09}" type="datetimeFigureOut">
               <a:rPr lang="en-US" smtClean="0"/>
               <a:pPr/>
-              <a:t>10/18/2026</a:t>
+              <a:t>10/19/26</a:t>
             </a:fld>
             <a:endParaRPr lang="en-US"/>
           </a:p>
@@ -1363,7 +1531,7 @@
             <a:fld id="{1D8BD707-D9CF-40AE-B4C6-C98DA3205C09}" type="datetimeFigureOut">
               <a:rPr lang="en-US" smtClean="0"/>
               <a:pPr/>
-              <a:t>10/18/2026</a:t>
+              <a:t>10/19/26</a:t>
             </a:fld>
             <a:endParaRPr lang="en-US"/>
           </a:p>
@@ -1528,7 +1696,7 @@
             <a:fld id="{1D8BD707-D9CF-40AE-B4C6-C98DA3205C09}" type="datetimeFigureOut">
               <a:rPr lang="en-US" smtClean="0"/>
               <a:pPr/>
-              <a:t>10/18/2026</a:t>
+              <a:t>10/19/26</a:t>
             </a:fld>
             <a:endParaRPr lang="en-US"/>
           </a:p>
@@ -1770,7 +1938,7 @@
             <a:fld id="{1D8BD707-D9CF-40AE-B4C6-C98DA3205C09}" type="datetimeFigureOut">
               <a:rPr lang="en-US" smtClean="0"/>
               <a:pPr/>
-              <a:t>10/18/2026</a:t>
+              <a:t>10/19/26</a:t>
             </a:fld>
             <a:endParaRPr lang="en-US"/>
           </a:p>
@@ -2052,7 +2220,7 @@
             <a:fld id="{1D8BD707-D9CF-40AE-B4C6-C98DA3205C09}" type="datetimeFigureOut">
               <a:rPr lang="en-US" smtClean="0"/>
               <a:pPr/>
-              <a:t>10/18/2026</a:t>
+              <a:t>10/19/26</a:t>
             </a:fld>
             <a:endParaRPr lang="en-US"/>
           </a:p>
@@ -2468,7 +2636,7 @@
             <a:fld id="{1D8BD707-D9CF-40AE-B4C6-C98DA3205C09}" type="datetimeFigureOut">
               <a:rPr lang="en-US" smtClean="0"/>
               <a:pPr/>
-              <a:t>10/18/2026</a:t>
+              <a:t>10/19/26</a:t>
             </a:fld>
             <a:endParaRPr lang="en-US"/>
           </a:p>
@@ -2582,7 +2750,7 @@
             <a:fld id="{1D8BD707-D9CF-40AE-B4C6-C98DA3205C09}" type="datetimeFigureOut">
               <a:rPr lang="en-US" smtClean="0"/>
               <a:pPr/>
-              <a:t>10/18/2026</a:t>
+              <a:t>10/19/26</a:t>
             </a:fld>
             <a:endParaRPr lang="en-US"/>
           </a:p>
@@ -2674,7 +2842,7 @@
             <a:fld id="{1D8BD707-D9CF-40AE-B4C6-C98DA3205C09}" type="datetimeFigureOut">
               <a:rPr lang="en-US" smtClean="0"/>
               <a:pPr/>
-              <a:t>10/18/2026</a:t>
+              <a:t>10/18/26</a:t>
             </a:fld>
             <a:endParaRPr lang="en-US"/>
           </a:p>
@@ -2946,7 +3114,7 @@
             <a:fld id="{1D8BD707-D9CF-40AE-B4C6-C98DA3205C09}" type="datetimeFigureOut">
               <a:rPr lang="en-US" smtClean="0"/>
               <a:pPr/>
-              <a:t>10/18/2026</a:t>
+              <a:t>10/19/26</a:t>
             </a:fld>
             <a:endParaRPr lang="en-US"/>
           </a:p>
@@ -3195,7 +3363,7 @@
             <a:fld id="{1D8BD707-D9CF-40AE-B4C6-C98DA3205C09}" type="datetimeFigureOut">
               <a:rPr lang="en-US" smtClean="0"/>
               <a:pPr/>
-              <a:t>10/18/2026</a:t>
+              <a:t>10/19/26</a:t>
             </a:fld>
             <a:endParaRPr lang="en-US"/>
           </a:p>
@@ -3403,7 +3571,7 @@
             <a:fld id="{1D8BD707-D9CF-40AE-B4C6-C98DA3205C09}" type="datetimeFigureOut">
               <a:rPr lang="en-US" smtClean="0"/>
               <a:pPr/>
-              <a:t>10/18/2026</a:t>
+              <a:t>10/18/26</a:t>
             </a:fld>
             <a:endParaRPr lang="en-US"/>
           </a:p>
@@ -3959,8 +4127,8 @@
         </p:nvSpPr>
         <p:spPr>
           <a:xfrm>
-            <a:off x="15486600" y="396902"/>
-            <a:ext cx="4114800" cy="4114800"/>
+            <a:off x="14660974" y="0"/>
+            <a:ext cx="3657600" cy="3657600"/>
           </a:xfrm>
           <a:custGeom>
             <a:avLst/>
@@ -4549,12 +4717,53 @@
           </a:p>
         </p:txBody>
       </p:sp>
+      <p:sp>
+        <p:nvSpPr>
+          <p:cNvPr id="5" name="TextBox 5"/>
+          <p:cNvSpPr txBox="1"/>
+          <p:nvPr/>
+        </p:nvSpPr>
+        <p:spPr>
+          <a:xfrm>
+            <a:off x="1698662" y="506637"/>
+            <a:ext cx="11331538" cy="1794722"/>
+          </a:xfrm>
+          <a:prstGeom prst="rect">
+            <a:avLst/>
+          </a:prstGeom>
+        </p:spPr>
+        <p:txBody>
+          <a:bodyPr wrap="square" lIns="0" tIns="0" rIns="0" bIns="0" rtlCol="0" anchor="t">
+            <a:spAutoFit/>
+          </a:bodyPr>
+          <a:lstStyle/>
+          <a:p>
+            <a:pPr algn="l">
+              <a:lnSpc>
+                <a:spcPts val="16050"/>
+              </a:lnSpc>
+            </a:pPr>
+            <a:r>
+              <a:rPr lang="en-US" sz="8000" b="1" dirty="0">
+                <a:solidFill>
+                  <a:srgbClr val="000000"/>
+                </a:solidFill>
+                <a:latin typeface="Alegreya Sans SC Bold"/>
+                <a:ea typeface="Alegreya Sans SC Bold"/>
+                <a:cs typeface="Alegreya Sans SC Bold"/>
+                <a:sym typeface="Alegreya Sans SC Bold"/>
+              </a:rPr>
+              <a:t>Bibliography</a:t>
+            </a:r>
+          </a:p>
+        </p:txBody>
+      </p:sp>
       <p:grpSp>
         <p:nvGrpSpPr>
-          <p:cNvPr id="8" name="Group 3">
+          <p:cNvPr id="11" name="Group 3">
             <a:extLst>
               <a:ext uri="{FF2B5EF4-FFF2-40B4-BE49-F238E27FC236}">
-                <a16:creationId xmlns:a16="http://schemas.microsoft.com/office/drawing/2014/main" id="{7AFBA427-7C1B-7F27-1234-F3217BEA4183}"/>
+                <a16:creationId xmlns:a16="http://schemas.microsoft.com/office/drawing/2014/main" id="{1E2B1ABA-5C13-0820-845E-6CCCD1A8B5BE}"/>
               </a:ext>
             </a:extLst>
           </p:cNvPr>
@@ -4563,18 +4772,18 @@
         </p:nvGrpSpPr>
         <p:grpSpPr>
           <a:xfrm>
-            <a:off x="223495" y="2411094"/>
-            <a:ext cx="17841010" cy="5247006"/>
+            <a:off x="223495" y="1943100"/>
+            <a:ext cx="17841010" cy="7467600"/>
             <a:chOff x="0" y="-38100"/>
             <a:chExt cx="1723392" cy="984671"/>
           </a:xfrm>
         </p:grpSpPr>
         <p:sp>
           <p:nvSpPr>
-            <p:cNvPr id="9" name="Freeform 4">
+            <p:cNvPr id="12" name="Freeform 4">
               <a:extLst>
                 <a:ext uri="{FF2B5EF4-FFF2-40B4-BE49-F238E27FC236}">
-                  <a16:creationId xmlns:a16="http://schemas.microsoft.com/office/drawing/2014/main" id="{391D8643-13D7-40AB-6864-77F1C1311A81}"/>
+                  <a16:creationId xmlns:a16="http://schemas.microsoft.com/office/drawing/2014/main" id="{F7D31518-F938-2298-79A9-09D3F27ADE1C}"/>
                 </a:ext>
               </a:extLst>
             </p:cNvPr>
@@ -4662,10 +4871,10 @@
         </p:sp>
         <p:sp>
           <p:nvSpPr>
-            <p:cNvPr id="10" name="TextBox 5">
+            <p:cNvPr id="13" name="TextBox 5">
               <a:extLst>
                 <a:ext uri="{FF2B5EF4-FFF2-40B4-BE49-F238E27FC236}">
-                  <a16:creationId xmlns:a16="http://schemas.microsoft.com/office/drawing/2014/main" id="{F2625F50-6BBC-42FE-B7F1-9FF2C55EA062}"/>
+                  <a16:creationId xmlns:a16="http://schemas.microsoft.com/office/drawing/2014/main" id="{9257CC23-25D3-54A3-0FFB-529C6CA138D8}"/>
                 </a:ext>
               </a:extLst>
             </p:cNvPr>
@@ -4700,47 +4909,6 @@
       </p:grpSp>
       <p:sp>
         <p:nvSpPr>
-          <p:cNvPr id="5" name="TextBox 5"/>
-          <p:cNvSpPr txBox="1"/>
-          <p:nvPr/>
-        </p:nvSpPr>
-        <p:spPr>
-          <a:xfrm>
-            <a:off x="1698662" y="506637"/>
-            <a:ext cx="11331538" cy="1794722"/>
-          </a:xfrm>
-          <a:prstGeom prst="rect">
-            <a:avLst/>
-          </a:prstGeom>
-        </p:spPr>
-        <p:txBody>
-          <a:bodyPr wrap="square" lIns="0" tIns="0" rIns="0" bIns="0" rtlCol="0" anchor="t">
-            <a:spAutoFit/>
-          </a:bodyPr>
-          <a:lstStyle/>
-          <a:p>
-            <a:pPr algn="l">
-              <a:lnSpc>
-                <a:spcPts val="16050"/>
-              </a:lnSpc>
-            </a:pPr>
-            <a:r>
-              <a:rPr lang="en-US" sz="8000" b="1" dirty="0">
-                <a:solidFill>
-                  <a:srgbClr val="000000"/>
-                </a:solidFill>
-                <a:latin typeface="Alegreya Sans SC Bold"/>
-                <a:ea typeface="Alegreya Sans SC Bold"/>
-                <a:cs typeface="Alegreya Sans SC Bold"/>
-                <a:sym typeface="Alegreya Sans SC Bold"/>
-              </a:rPr>
-              <a:t>Bibliography</a:t>
-            </a:r>
-          </a:p>
-        </p:txBody>
-      </p:sp>
-      <p:sp>
-        <p:nvSpPr>
           <p:cNvPr id="7" name="TextBox 6">
             <a:extLst>
               <a:ext uri="{FF2B5EF4-FFF2-40B4-BE49-F238E27FC236}">
@@ -5250,66 +5418,6 @@
               <a:extLst>
                 <a:ext uri="{96DAC541-7B7A-43D3-8B79-37D633B846F1}">
                   <asvg:svgBlip xmlns:asvg="http://schemas.microsoft.com/office/drawing/2016/SVG/main" r:embed="rId3"/>
-                </a:ext>
-              </a:extLst>
-            </a:blip>
-            <a:stretch>
-              <a:fillRect/>
-            </a:stretch>
-          </a:blipFill>
-        </p:spPr>
-        <p:txBody>
-          <a:bodyPr/>
-          <a:lstStyle/>
-          <a:p>
-            <a:endParaRPr lang="en-CA"/>
-          </a:p>
-        </p:txBody>
-      </p:sp>
-      <p:sp>
-        <p:nvSpPr>
-          <p:cNvPr id="5" name="Freeform 5"/>
-          <p:cNvSpPr/>
-          <p:nvPr/>
-        </p:nvSpPr>
-        <p:spPr>
-          <a:xfrm>
-            <a:off x="14716060" y="0"/>
-            <a:ext cx="3612154" cy="3612154"/>
-          </a:xfrm>
-          <a:custGeom>
-            <a:avLst/>
-            <a:gdLst/>
-            <a:ahLst/>
-            <a:cxnLst/>
-            <a:rect l="l" t="t" r="r" b="b"/>
-            <a:pathLst>
-              <a:path w="4114800" h="4114800">
-                <a:moveTo>
-                  <a:pt x="0" y="0"/>
-                </a:moveTo>
-                <a:lnTo>
-                  <a:pt x="4114800" y="0"/>
-                </a:lnTo>
-                <a:lnTo>
-                  <a:pt x="4114800" y="4114800"/>
-                </a:lnTo>
-                <a:lnTo>
-                  <a:pt x="0" y="4114800"/>
-                </a:lnTo>
-                <a:lnTo>
-                  <a:pt x="0" y="0"/>
-                </a:lnTo>
-                <a:close/>
-              </a:path>
-            </a:pathLst>
-          </a:custGeom>
-          <a:blipFill>
-            <a:blip>
-              <a:alphaModFix amt="24000"/>
-              <a:extLst>
-                <a:ext uri="{96DAC541-7B7A-43D3-8B79-37D633B846F1}">
-                  <asvg:svgBlip xmlns:asvg="http://schemas.microsoft.com/office/drawing/2016/SVG/main" r:embed="rId4"/>
                 </a:ext>
               </a:extLst>
             </a:blip>
@@ -5525,8 +5633,8 @@
         </p:nvSpPr>
         <p:spPr>
           <a:xfrm>
-            <a:off x="3820326" y="800100"/>
-            <a:ext cx="10151901" cy="2205732"/>
+            <a:off x="1554562" y="1288581"/>
+            <a:ext cx="12195985" cy="2205732"/>
           </a:xfrm>
           <a:prstGeom prst="rect">
             <a:avLst/>
@@ -5778,8 +5886,8 @@
         </p:nvSpPr>
         <p:spPr>
           <a:xfrm>
-            <a:off x="8790888" y="9748662"/>
-            <a:ext cx="4834517" cy="369332"/>
+            <a:off x="12115800" y="9650247"/>
+            <a:ext cx="5791201" cy="369332"/>
           </a:xfrm>
           <a:prstGeom prst="rect">
             <a:avLst/>
@@ -5791,7 +5899,7 @@
           </a:bodyPr>
           <a:lstStyle/>
           <a:p>
-            <a:pPr marL="259080" lvl="1">
+            <a:pPr marL="259080" lvl="1" algn="r">
               <a:lnSpc>
                 <a:spcPct val="100000"/>
               </a:lnSpc>
@@ -5829,7 +5937,7 @@
         </p:nvSpPr>
         <p:spPr>
           <a:xfrm>
-            <a:off x="4061760" y="9712108"/>
+            <a:off x="3894623" y="9598266"/>
             <a:ext cx="4834517" cy="369332"/>
           </a:xfrm>
           <a:prstGeom prst="rect">
@@ -5871,6 +5979,72 @@
               <a:cs typeface="Open Sans"/>
               <a:sym typeface="Open Sans"/>
             </a:endParaRPr>
+          </a:p>
+        </p:txBody>
+      </p:sp>
+      <p:sp>
+        <p:nvSpPr>
+          <p:cNvPr id="16" name="Freeform 5">
+            <a:extLst>
+              <a:ext uri="{FF2B5EF4-FFF2-40B4-BE49-F238E27FC236}">
+                <a16:creationId xmlns:a16="http://schemas.microsoft.com/office/drawing/2014/main" id="{993F4CDB-B733-1DDC-1513-7FA5C69F7C66}"/>
+              </a:ext>
+            </a:extLst>
+          </p:cNvPr>
+          <p:cNvSpPr/>
+          <p:nvPr/>
+        </p:nvSpPr>
+        <p:spPr>
+          <a:xfrm>
+            <a:off x="14660974" y="0"/>
+            <a:ext cx="3657600" cy="3657600"/>
+          </a:xfrm>
+          <a:custGeom>
+            <a:avLst/>
+            <a:gdLst/>
+            <a:ahLst/>
+            <a:cxnLst/>
+            <a:rect l="l" t="t" r="r" b="b"/>
+            <a:pathLst>
+              <a:path w="4114800" h="4114800">
+                <a:moveTo>
+                  <a:pt x="0" y="0"/>
+                </a:moveTo>
+                <a:lnTo>
+                  <a:pt x="4114800" y="0"/>
+                </a:lnTo>
+                <a:lnTo>
+                  <a:pt x="4114800" y="4114800"/>
+                </a:lnTo>
+                <a:lnTo>
+                  <a:pt x="0" y="4114800"/>
+                </a:lnTo>
+                <a:lnTo>
+                  <a:pt x="0" y="0"/>
+                </a:lnTo>
+                <a:close/>
+              </a:path>
+            </a:pathLst>
+          </a:custGeom>
+          <a:blipFill>
+            <a:blip>
+              <a:alphaModFix amt="24000"/>
+              <a:extLst>
+                <a:ext uri="{96DAC541-7B7A-43D3-8B79-37D633B846F1}">
+                  <asvg:svgBlip xmlns:asvg="http://schemas.microsoft.com/office/drawing/2016/SVG/main" r:embed="rId4"/>
+                </a:ext>
+              </a:extLst>
+            </a:blip>
+            <a:stretch>
+              <a:fillRect/>
+            </a:stretch>
+          </a:blipFill>
+        </p:spPr>
+        <p:txBody>
+          <a:bodyPr/>
+          <a:lstStyle/>
+          <a:p>
+            <a:endParaRPr lang="en-CA"/>
           </a:p>
         </p:txBody>
       </p:sp>
@@ -5953,7 +6127,7 @@
             <a:blip>
               <a:extLst>
                 <a:ext uri="{96DAC541-7B7A-43D3-8B79-37D633B846F1}">
-                  <asvg:svgBlip xmlns:asvg="http://schemas.microsoft.com/office/drawing/2016/SVG/main" r:embed="rId2"/>
+                  <asvg:svgBlip xmlns:asvg="http://schemas.microsoft.com/office/drawing/2016/SVG/main" r:embed="rId3"/>
                 </a:ext>
               </a:extLst>
             </a:blip>
@@ -6018,7 +6192,7 @@
             <a:blip>
               <a:extLst>
                 <a:ext uri="{96DAC541-7B7A-43D3-8B79-37D633B846F1}">
-                  <asvg:svgBlip xmlns:asvg="http://schemas.microsoft.com/office/drawing/2016/SVG/main" r:embed="rId3"/>
+                  <asvg:svgBlip xmlns:asvg="http://schemas.microsoft.com/office/drawing/2016/SVG/main" r:embed="rId4"/>
                 </a:ext>
               </a:extLst>
             </a:blip>
@@ -6083,72 +6257,6 @@
             <a:blip>
               <a:extLst>
                 <a:ext uri="{96DAC541-7B7A-43D3-8B79-37D633B846F1}">
-                  <asvg:svgBlip xmlns:asvg="http://schemas.microsoft.com/office/drawing/2016/SVG/main" r:embed="rId3"/>
-                </a:ext>
-              </a:extLst>
-            </a:blip>
-            <a:stretch>
-              <a:fillRect/>
-            </a:stretch>
-          </a:blipFill>
-        </p:spPr>
-        <p:txBody>
-          <a:bodyPr/>
-          <a:lstStyle/>
-          <a:p>
-            <a:endParaRPr lang="en-CA"/>
-          </a:p>
-        </p:txBody>
-      </p:sp>
-      <p:sp>
-        <p:nvSpPr>
-          <p:cNvPr id="5" name="Freeform 5">
-            <a:extLst>
-              <a:ext uri="{FF2B5EF4-FFF2-40B4-BE49-F238E27FC236}">
-                <a16:creationId xmlns:a16="http://schemas.microsoft.com/office/drawing/2014/main" id="{5DE8145F-90C6-1A73-7399-5FC9087E243F}"/>
-              </a:ext>
-            </a:extLst>
-          </p:cNvPr>
-          <p:cNvSpPr/>
-          <p:nvPr/>
-        </p:nvSpPr>
-        <p:spPr>
-          <a:xfrm>
-            <a:off x="14727258" y="-3652"/>
-            <a:ext cx="3612154" cy="3641629"/>
-          </a:xfrm>
-          <a:custGeom>
-            <a:avLst/>
-            <a:gdLst/>
-            <a:ahLst/>
-            <a:cxnLst/>
-            <a:rect l="l" t="t" r="r" b="b"/>
-            <a:pathLst>
-              <a:path w="4114800" h="4114800">
-                <a:moveTo>
-                  <a:pt x="0" y="0"/>
-                </a:moveTo>
-                <a:lnTo>
-                  <a:pt x="4114800" y="0"/>
-                </a:lnTo>
-                <a:lnTo>
-                  <a:pt x="4114800" y="4114800"/>
-                </a:lnTo>
-                <a:lnTo>
-                  <a:pt x="0" y="4114800"/>
-                </a:lnTo>
-                <a:lnTo>
-                  <a:pt x="0" y="0"/>
-                </a:lnTo>
-                <a:close/>
-              </a:path>
-            </a:pathLst>
-          </a:custGeom>
-          <a:blipFill>
-            <a:blip>
-              <a:alphaModFix amt="24000"/>
-              <a:extLst>
-                <a:ext uri="{96DAC541-7B7A-43D3-8B79-37D633B846F1}">
                   <asvg:svgBlip xmlns:asvg="http://schemas.microsoft.com/office/drawing/2016/SVG/main" r:embed="rId4"/>
                 </a:ext>
               </a:extLst>
@@ -6215,7 +6323,7 @@
               <a:alphaModFix amt="24000"/>
               <a:extLst>
                 <a:ext uri="{96DAC541-7B7A-43D3-8B79-37D633B846F1}">
-                  <asvg:svgBlip xmlns:asvg="http://schemas.microsoft.com/office/drawing/2016/SVG/main" r:embed="rId4"/>
+                  <asvg:svgBlip xmlns:asvg="http://schemas.microsoft.com/office/drawing/2016/SVG/main" r:embed="rId5"/>
                 </a:ext>
               </a:extLst>
             </a:blip>
@@ -6246,8 +6354,8 @@
         </p:nvSpPr>
         <p:spPr>
           <a:xfrm>
-            <a:off x="4748331" y="550443"/>
-            <a:ext cx="8580038" cy="2205732"/>
+            <a:off x="2163310" y="1236691"/>
+            <a:ext cx="11357750" cy="2205732"/>
           </a:xfrm>
           <a:prstGeom prst="rect">
             <a:avLst/>
@@ -6294,14 +6402,14 @@
           <p:nvPr/>
         </p:nvPicPr>
         <p:blipFill>
-          <a:blip r:embed="rId5"/>
+          <a:blip r:embed="rId6"/>
           <a:stretch>
             <a:fillRect/>
           </a:stretch>
         </p:blipFill>
         <p:spPr>
           <a:xfrm>
-            <a:off x="3706033" y="3044349"/>
+            <a:off x="2590100" y="3402318"/>
             <a:ext cx="11072635" cy="6643766"/>
           </a:xfrm>
           <a:prstGeom prst="rect">
@@ -6330,8 +6438,8 @@
         </p:nvSpPr>
         <p:spPr>
           <a:xfrm>
-            <a:off x="12039601" y="9830827"/>
-            <a:ext cx="3667439" cy="738664"/>
+            <a:off x="12181751" y="9863448"/>
+            <a:ext cx="5343840" cy="369332"/>
           </a:xfrm>
           <a:prstGeom prst="rect">
             <a:avLst/>
@@ -6364,6 +6472,72 @@
               <a:cs typeface="Open Sans"/>
               <a:sym typeface="Open Sans"/>
             </a:endParaRPr>
+          </a:p>
+        </p:txBody>
+      </p:sp>
+      <p:sp>
+        <p:nvSpPr>
+          <p:cNvPr id="7" name="Freeform 5">
+            <a:extLst>
+              <a:ext uri="{FF2B5EF4-FFF2-40B4-BE49-F238E27FC236}">
+                <a16:creationId xmlns:a16="http://schemas.microsoft.com/office/drawing/2014/main" id="{F5ED3CE8-0C18-0E81-119D-F1E064EA8EF3}"/>
+              </a:ext>
+            </a:extLst>
+          </p:cNvPr>
+          <p:cNvSpPr/>
+          <p:nvPr/>
+        </p:nvSpPr>
+        <p:spPr>
+          <a:xfrm>
+            <a:off x="14660974" y="0"/>
+            <a:ext cx="3657600" cy="3657600"/>
+          </a:xfrm>
+          <a:custGeom>
+            <a:avLst/>
+            <a:gdLst/>
+            <a:ahLst/>
+            <a:cxnLst/>
+            <a:rect l="l" t="t" r="r" b="b"/>
+            <a:pathLst>
+              <a:path w="4114800" h="4114800">
+                <a:moveTo>
+                  <a:pt x="0" y="0"/>
+                </a:moveTo>
+                <a:lnTo>
+                  <a:pt x="4114800" y="0"/>
+                </a:lnTo>
+                <a:lnTo>
+                  <a:pt x="4114800" y="4114800"/>
+                </a:lnTo>
+                <a:lnTo>
+                  <a:pt x="0" y="4114800"/>
+                </a:lnTo>
+                <a:lnTo>
+                  <a:pt x="0" y="0"/>
+                </a:lnTo>
+                <a:close/>
+              </a:path>
+            </a:pathLst>
+          </a:custGeom>
+          <a:blipFill>
+            <a:blip>
+              <a:alphaModFix amt="24000"/>
+              <a:extLst>
+                <a:ext uri="{96DAC541-7B7A-43D3-8B79-37D633B846F1}">
+                  <asvg:svgBlip xmlns:asvg="http://schemas.microsoft.com/office/drawing/2016/SVG/main" r:embed="rId5"/>
+                </a:ext>
+              </a:extLst>
+            </a:blip>
+            <a:stretch>
+              <a:fillRect/>
+            </a:stretch>
+          </a:blipFill>
+        </p:spPr>
+        <p:txBody>
+          <a:bodyPr/>
+          <a:lstStyle/>
+          <a:p>
+            <a:endParaRPr lang="en-CA"/>
           </a:p>
         </p:txBody>
       </p:sp>
@@ -6439,7 +6613,7 @@
             <a:blip>
               <a:extLst>
                 <a:ext uri="{96DAC541-7B7A-43D3-8B79-37D633B846F1}">
-                  <asvg:svgBlip xmlns:asvg="http://schemas.microsoft.com/office/drawing/2016/SVG/main" r:embed="rId2"/>
+                  <asvg:svgBlip xmlns:asvg="http://schemas.microsoft.com/office/drawing/2016/SVG/main" r:embed="rId3"/>
                 </a:ext>
               </a:extLst>
             </a:blip>
@@ -6452,7 +6626,7 @@
           <a:bodyPr/>
           <a:lstStyle/>
           <a:p>
-            <a:endParaRPr lang="en-CA"/>
+            <a:endParaRPr lang="en-CA" dirty="0"/>
           </a:p>
         </p:txBody>
       </p:sp>
@@ -6629,7 +6803,7 @@
             <a:blip>
               <a:extLst>
                 <a:ext uri="{96DAC541-7B7A-43D3-8B79-37D633B846F1}">
-                  <asvg:svgBlip xmlns:asvg="http://schemas.microsoft.com/office/drawing/2016/SVG/main" r:embed="rId3"/>
+                  <asvg:svgBlip xmlns:asvg="http://schemas.microsoft.com/office/drawing/2016/SVG/main" r:embed="rId4"/>
                 </a:ext>
               </a:extLst>
             </a:blip>
@@ -6688,7 +6862,7 @@
             <a:blip>
               <a:extLst>
                 <a:ext uri="{96DAC541-7B7A-43D3-8B79-37D633B846F1}">
-                  <asvg:svgBlip xmlns:asvg="http://schemas.microsoft.com/office/drawing/2016/SVG/main" r:embed="rId3"/>
+                  <asvg:svgBlip xmlns:asvg="http://schemas.microsoft.com/office/drawing/2016/SVG/main" r:embed="rId4"/>
                 </a:ext>
               </a:extLst>
             </a:blip>
@@ -6828,73 +7002,13 @@
       </p:grpSp>
       <p:sp>
         <p:nvSpPr>
-          <p:cNvPr id="11" name="Freeform 11"/>
-          <p:cNvSpPr/>
-          <p:nvPr/>
-        </p:nvSpPr>
-        <p:spPr>
-          <a:xfrm>
-            <a:off x="14716060" y="-85440"/>
-            <a:ext cx="3612154" cy="3612154"/>
-          </a:xfrm>
-          <a:custGeom>
-            <a:avLst/>
-            <a:gdLst/>
-            <a:ahLst/>
-            <a:cxnLst/>
-            <a:rect l="l" t="t" r="r" b="b"/>
-            <a:pathLst>
-              <a:path w="4114800" h="4114800">
-                <a:moveTo>
-                  <a:pt x="0" y="0"/>
-                </a:moveTo>
-                <a:lnTo>
-                  <a:pt x="4114800" y="0"/>
-                </a:lnTo>
-                <a:lnTo>
-                  <a:pt x="4114800" y="4114800"/>
-                </a:lnTo>
-                <a:lnTo>
-                  <a:pt x="0" y="4114800"/>
-                </a:lnTo>
-                <a:lnTo>
-                  <a:pt x="0" y="0"/>
-                </a:lnTo>
-                <a:close/>
-              </a:path>
-            </a:pathLst>
-          </a:custGeom>
-          <a:blipFill>
-            <a:blip>
-              <a:alphaModFix amt="24000"/>
-              <a:extLst>
-                <a:ext uri="{96DAC541-7B7A-43D3-8B79-37D633B846F1}">
-                  <asvg:svgBlip xmlns:asvg="http://schemas.microsoft.com/office/drawing/2016/SVG/main" r:embed="rId4"/>
-                </a:ext>
-              </a:extLst>
-            </a:blip>
-            <a:stretch>
-              <a:fillRect/>
-            </a:stretch>
-          </a:blipFill>
-        </p:spPr>
-        <p:txBody>
-          <a:bodyPr/>
-          <a:lstStyle/>
-          <a:p>
-            <a:endParaRPr lang="en-CA"/>
-          </a:p>
-        </p:txBody>
-      </p:sp>
-      <p:sp>
-        <p:nvSpPr>
           <p:cNvPr id="16" name="TextBox 16"/>
           <p:cNvSpPr txBox="1"/>
           <p:nvPr/>
         </p:nvSpPr>
         <p:spPr>
           <a:xfrm>
-            <a:off x="3781860" y="881163"/>
+            <a:off x="2383303" y="1280359"/>
             <a:ext cx="10431349" cy="1127683"/>
           </a:xfrm>
           <a:prstGeom prst="rect">
@@ -6913,7 +7027,7 @@
               </a:lnSpc>
             </a:pPr>
             <a:r>
-              <a:rPr lang="en-US" sz="8000" b="1">
+              <a:rPr lang="en-US" sz="8000" b="1" dirty="0">
                 <a:solidFill>
                   <a:srgbClr val="000000"/>
                 </a:solidFill>
@@ -6936,7 +7050,7 @@
         <p:spPr>
           <a:xfrm>
             <a:off x="682357" y="3862827"/>
-            <a:ext cx="11447776" cy="2158732"/>
+            <a:ext cx="11447776" cy="1604735"/>
           </a:xfrm>
           <a:prstGeom prst="rect">
             <a:avLst/>
@@ -7016,53 +7130,7 @@
                 <a:cs typeface="Open Sans"/>
                 <a:sym typeface="Open Sans"/>
               </a:rPr>
-              <a:t>RSA keys are commonly 2048 bits.)</a:t>
-            </a:r>
-          </a:p>
-          <a:p>
-            <a:pPr marL="259080" lvl="1" algn="r">
-              <a:lnSpc>
-                <a:spcPct val="150000"/>
-              </a:lnSpc>
-              <a:spcBef>
-                <a:spcPct val="0"/>
-              </a:spcBef>
-            </a:pPr>
-            <a:r>
-              <a:rPr lang="en-US" sz="2400" dirty="0">
-                <a:solidFill>
-                  <a:srgbClr val="000000"/>
-                </a:solidFill>
-                <a:latin typeface="Candara" panose="020E0502030303020204" pitchFamily="34" charset="0"/>
-                <a:ea typeface="Open Sans"/>
-                <a:cs typeface="Open Sans"/>
-                <a:sym typeface="Open Sans"/>
-              </a:rPr>
-              <a:t>(</a:t>
-            </a:r>
-            <a:r>
-              <a:rPr lang="en-US" sz="2400" dirty="0" err="1">
-                <a:solidFill>
-                  <a:srgbClr val="000000"/>
-                </a:solidFill>
-                <a:latin typeface="Candara" panose="020E0502030303020204" pitchFamily="34" charset="0"/>
-                <a:ea typeface="Open Sans"/>
-                <a:cs typeface="Open Sans"/>
-                <a:sym typeface="Open Sans"/>
-              </a:rPr>
-              <a:t>GeeksforGeeks</a:t>
-            </a:r>
-            <a:r>
-              <a:rPr lang="en-US" sz="2400" dirty="0">
-                <a:solidFill>
-                  <a:srgbClr val="000000"/>
-                </a:solidFill>
-                <a:latin typeface="Candara" panose="020E0502030303020204" pitchFamily="34" charset="0"/>
-                <a:ea typeface="Open Sans"/>
-                <a:cs typeface="Open Sans"/>
-                <a:sym typeface="Open Sans"/>
-              </a:rPr>
-              <a:t>, 2025; Ireland, n.d.)</a:t>
+              <a:t>RSA keys are commonly 2048 bits.</a:t>
             </a:r>
           </a:p>
         </p:txBody>
@@ -7323,7 +7391,7 @@
         </p:nvSpPr>
         <p:spPr>
           <a:xfrm>
-            <a:off x="4618432" y="1645641"/>
+            <a:off x="3117682" y="2014324"/>
             <a:ext cx="8962589" cy="961802"/>
           </a:xfrm>
           <a:prstGeom prst="rect">
@@ -7695,6 +7763,72 @@
       </p:sp>
       <p:sp>
         <p:nvSpPr>
+          <p:cNvPr id="15" name="Freeform 5">
+            <a:extLst>
+              <a:ext uri="{FF2B5EF4-FFF2-40B4-BE49-F238E27FC236}">
+                <a16:creationId xmlns:a16="http://schemas.microsoft.com/office/drawing/2014/main" id="{A68CF381-B1AE-C849-91E7-85B6F10B603C}"/>
+              </a:ext>
+            </a:extLst>
+          </p:cNvPr>
+          <p:cNvSpPr/>
+          <p:nvPr/>
+        </p:nvSpPr>
+        <p:spPr>
+          <a:xfrm>
+            <a:off x="14660974" y="0"/>
+            <a:ext cx="3657600" cy="3657600"/>
+          </a:xfrm>
+          <a:custGeom>
+            <a:avLst/>
+            <a:gdLst/>
+            <a:ahLst/>
+            <a:cxnLst/>
+            <a:rect l="l" t="t" r="r" b="b"/>
+            <a:pathLst>
+              <a:path w="4114800" h="4114800">
+                <a:moveTo>
+                  <a:pt x="0" y="0"/>
+                </a:moveTo>
+                <a:lnTo>
+                  <a:pt x="4114800" y="0"/>
+                </a:lnTo>
+                <a:lnTo>
+                  <a:pt x="4114800" y="4114800"/>
+                </a:lnTo>
+                <a:lnTo>
+                  <a:pt x="0" y="4114800"/>
+                </a:lnTo>
+                <a:lnTo>
+                  <a:pt x="0" y="0"/>
+                </a:lnTo>
+                <a:close/>
+              </a:path>
+            </a:pathLst>
+          </a:custGeom>
+          <a:blipFill>
+            <a:blip>
+              <a:alphaModFix amt="24000"/>
+              <a:extLst>
+                <a:ext uri="{96DAC541-7B7A-43D3-8B79-37D633B846F1}">
+                  <asvg:svgBlip xmlns:asvg="http://schemas.microsoft.com/office/drawing/2016/SVG/main" r:embed="rId6"/>
+                </a:ext>
+              </a:extLst>
+            </a:blip>
+            <a:stretch>
+              <a:fillRect/>
+            </a:stretch>
+          </a:blipFill>
+        </p:spPr>
+        <p:txBody>
+          <a:bodyPr/>
+          <a:lstStyle/>
+          <a:p>
+            <a:endParaRPr lang="en-CA"/>
+          </a:p>
+        </p:txBody>
+      </p:sp>
+      <p:sp>
+        <p:nvSpPr>
           <p:cNvPr id="36" name="TextBox 20">
             <a:extLst>
               <a:ext uri="{FF2B5EF4-FFF2-40B4-BE49-F238E27FC236}">
@@ -7707,8 +7841,8 @@
         </p:nvSpPr>
         <p:spPr>
           <a:xfrm>
-            <a:off x="12821143" y="9840203"/>
-            <a:ext cx="6468985" cy="369332"/>
+            <a:off x="11128263" y="9776231"/>
+            <a:ext cx="6945728" cy="369332"/>
           </a:xfrm>
           <a:prstGeom prst="rect">
             <a:avLst/>
@@ -7741,6 +7875,80 @@
               <a:cs typeface="Open Sans"/>
               <a:sym typeface="Open Sans"/>
             </a:endParaRPr>
+          </a:p>
+        </p:txBody>
+      </p:sp>
+      <p:sp>
+        <p:nvSpPr>
+          <p:cNvPr id="17" name="TextBox 20">
+            <a:extLst>
+              <a:ext uri="{FF2B5EF4-FFF2-40B4-BE49-F238E27FC236}">
+                <a16:creationId xmlns:a16="http://schemas.microsoft.com/office/drawing/2014/main" id="{1726AC43-1B4C-283D-4517-72698456DDED}"/>
+              </a:ext>
+            </a:extLst>
+          </p:cNvPr>
+          <p:cNvSpPr txBox="1"/>
+          <p:nvPr/>
+        </p:nvSpPr>
+        <p:spPr>
+          <a:xfrm>
+            <a:off x="7849476" y="5451994"/>
+            <a:ext cx="5270864" cy="496739"/>
+          </a:xfrm>
+          <a:prstGeom prst="rect">
+            <a:avLst/>
+          </a:prstGeom>
+        </p:spPr>
+        <p:txBody>
+          <a:bodyPr wrap="square" lIns="0" tIns="0" rIns="0" bIns="0" rtlCol="0" anchor="t">
+            <a:spAutoFit/>
+          </a:bodyPr>
+          <a:lstStyle/>
+          <a:p>
+            <a:pPr marL="259080" lvl="1" algn="r">
+              <a:lnSpc>
+                <a:spcPct val="150000"/>
+              </a:lnSpc>
+              <a:spcBef>
+                <a:spcPct val="0"/>
+              </a:spcBef>
+            </a:pPr>
+            <a:r>
+              <a:rPr lang="en-US" sz="2400" dirty="0">
+                <a:solidFill>
+                  <a:srgbClr val="000000"/>
+                </a:solidFill>
+                <a:latin typeface="Candara" panose="020E0502030303020204" pitchFamily="34" charset="0"/>
+                <a:ea typeface="Open Sans"/>
+                <a:cs typeface="Open Sans"/>
+                <a:sym typeface="Open Sans"/>
+              </a:rPr>
+              <a:t>(</a:t>
+            </a:r>
+            <a:r>
+              <a:rPr lang="en-US" sz="2400" dirty="0" err="1">
+                <a:solidFill>
+                  <a:srgbClr val="000000"/>
+                </a:solidFill>
+                <a:latin typeface="Candara" panose="020E0502030303020204" pitchFamily="34" charset="0"/>
+                <a:ea typeface="Open Sans"/>
+                <a:cs typeface="Open Sans"/>
+                <a:sym typeface="Open Sans"/>
+              </a:rPr>
+              <a:t>GeeksforGeeks</a:t>
+            </a:r>
+            <a:r>
+              <a:rPr lang="en-US" sz="2400" dirty="0">
+                <a:solidFill>
+                  <a:srgbClr val="000000"/>
+                </a:solidFill>
+                <a:latin typeface="Candara" panose="020E0502030303020204" pitchFamily="34" charset="0"/>
+                <a:ea typeface="Open Sans"/>
+                <a:cs typeface="Open Sans"/>
+                <a:sym typeface="Open Sans"/>
+              </a:rPr>
+              <a:t>, 2025; Ireland, n.d.)</a:t>
+            </a:r>
           </a:p>
         </p:txBody>
       </p:sp>
@@ -7824,7 +8032,7 @@
           <a:bodyPr/>
           <a:lstStyle/>
           <a:p>
-            <a:endParaRPr lang="en-CA"/>
+            <a:endParaRPr lang="en-CA" dirty="0"/>
           </a:p>
         </p:txBody>
       </p:sp>
@@ -7930,66 +8138,6 @@
               <a:extLst>
                 <a:ext uri="{96DAC541-7B7A-43D3-8B79-37D633B846F1}">
                   <asvg:svgBlip xmlns:asvg="http://schemas.microsoft.com/office/drawing/2016/SVG/main" r:embed="rId4"/>
-                </a:ext>
-              </a:extLst>
-            </a:blip>
-            <a:stretch>
-              <a:fillRect/>
-            </a:stretch>
-          </a:blipFill>
-        </p:spPr>
-        <p:txBody>
-          <a:bodyPr/>
-          <a:lstStyle/>
-          <a:p>
-            <a:endParaRPr lang="en-CA"/>
-          </a:p>
-        </p:txBody>
-      </p:sp>
-      <p:sp>
-        <p:nvSpPr>
-          <p:cNvPr id="5" name="Freeform 5"/>
-          <p:cNvSpPr/>
-          <p:nvPr/>
-        </p:nvSpPr>
-        <p:spPr>
-          <a:xfrm>
-            <a:off x="15156774" y="-165203"/>
-            <a:ext cx="3612154" cy="3612154"/>
-          </a:xfrm>
-          <a:custGeom>
-            <a:avLst/>
-            <a:gdLst/>
-            <a:ahLst/>
-            <a:cxnLst/>
-            <a:rect l="l" t="t" r="r" b="b"/>
-            <a:pathLst>
-              <a:path w="4114800" h="4114800">
-                <a:moveTo>
-                  <a:pt x="0" y="0"/>
-                </a:moveTo>
-                <a:lnTo>
-                  <a:pt x="4114800" y="0"/>
-                </a:lnTo>
-                <a:lnTo>
-                  <a:pt x="4114800" y="4114800"/>
-                </a:lnTo>
-                <a:lnTo>
-                  <a:pt x="0" y="4114800"/>
-                </a:lnTo>
-                <a:lnTo>
-                  <a:pt x="0" y="0"/>
-                </a:lnTo>
-                <a:close/>
-              </a:path>
-            </a:pathLst>
-          </a:custGeom>
-          <a:blipFill>
-            <a:blip>
-              <a:alphaModFix amt="24000"/>
-              <a:extLst>
-                <a:ext uri="{96DAC541-7B7A-43D3-8B79-37D633B846F1}">
-                  <asvg:svgBlip xmlns:asvg="http://schemas.microsoft.com/office/drawing/2016/SVG/main" r:embed="rId5"/>
                 </a:ext>
               </a:extLst>
             </a:blip>
@@ -8236,8 +8384,8 @@
         </p:nvSpPr>
         <p:spPr>
           <a:xfrm>
-            <a:off x="770454" y="4709710"/>
-            <a:ext cx="8090477" cy="5482719"/>
+            <a:off x="742729" y="4654278"/>
+            <a:ext cx="8090477" cy="4374724"/>
           </a:xfrm>
           <a:prstGeom prst="rect">
             <a:avLst/>
@@ -8354,50 +8502,10 @@
             </a:r>
           </a:p>
           <a:p>
-            <a:pPr marL="518160" lvl="1" indent="-259080">
+            <a:pPr marL="259080" lvl="1">
               <a:lnSpc>
                 <a:spcPct val="150000"/>
               </a:lnSpc>
-              <a:buFont typeface="Arial"/>
-              <a:buChar char="•"/>
-            </a:pPr>
-            <a:endParaRPr lang="en-US" sz="2400" dirty="0">
-              <a:solidFill>
-                <a:srgbClr val="000000"/>
-              </a:solidFill>
-              <a:latin typeface="Candara" panose="020E0502030303020204" pitchFamily="34" charset="0"/>
-              <a:ea typeface="Aileron"/>
-              <a:cs typeface="Aileron"/>
-              <a:sym typeface="Aileron"/>
-            </a:endParaRPr>
-          </a:p>
-          <a:p>
-            <a:pPr marL="259080" lvl="1" algn="r">
-              <a:lnSpc>
-                <a:spcPct val="150000"/>
-              </a:lnSpc>
-            </a:pPr>
-            <a:r>
-              <a:rPr lang="en-KR" sz="2400" dirty="0"/>
-              <a:t>(Tucker, 2024; Rescorla, 2018)</a:t>
-            </a:r>
-            <a:endParaRPr lang="en-US" sz="2400" dirty="0">
-              <a:solidFill>
-                <a:srgbClr val="000000"/>
-              </a:solidFill>
-              <a:latin typeface="Candara" panose="020E0502030303020204" pitchFamily="34" charset="0"/>
-              <a:ea typeface="Aileron"/>
-              <a:cs typeface="Aileron"/>
-              <a:sym typeface="Aileron"/>
-            </a:endParaRPr>
-          </a:p>
-          <a:p>
-            <a:pPr marL="518160" lvl="1" indent="-259080">
-              <a:lnSpc>
-                <a:spcPct val="150000"/>
-              </a:lnSpc>
-              <a:buFont typeface="Arial"/>
-              <a:buChar char="•"/>
             </a:pPr>
             <a:endParaRPr lang="en-US" sz="2400" dirty="0">
               <a:solidFill>
@@ -8506,8 +8614,8 @@
         </p:nvSpPr>
         <p:spPr>
           <a:xfrm>
-            <a:off x="9066181" y="9009611"/>
-            <a:ext cx="2577657" cy="738664"/>
+            <a:off x="14020800" y="8689749"/>
+            <a:ext cx="3811619" cy="369332"/>
           </a:xfrm>
           <a:prstGeom prst="rect">
             <a:avLst/>
@@ -8538,6 +8646,123 @@
             <a:r>
               <a:rPr lang="en-US" sz="2400" dirty="0"/>
               <a:t>, n.d.)</a:t>
+            </a:r>
+            <a:endParaRPr lang="en-US" sz="2400" dirty="0">
+              <a:solidFill>
+                <a:srgbClr val="000000"/>
+              </a:solidFill>
+              <a:latin typeface="Candara" panose="020E0502030303020204" pitchFamily="34" charset="0"/>
+              <a:ea typeface="Open Sans"/>
+              <a:cs typeface="Open Sans"/>
+              <a:sym typeface="Open Sans"/>
+            </a:endParaRPr>
+          </a:p>
+        </p:txBody>
+      </p:sp>
+      <p:sp>
+        <p:nvSpPr>
+          <p:cNvPr id="16" name="Freeform 5">
+            <a:extLst>
+              <a:ext uri="{FF2B5EF4-FFF2-40B4-BE49-F238E27FC236}">
+                <a16:creationId xmlns:a16="http://schemas.microsoft.com/office/drawing/2014/main" id="{2D9F9E34-2F1E-226B-1EDF-F6B064263AC9}"/>
+              </a:ext>
+            </a:extLst>
+          </p:cNvPr>
+          <p:cNvSpPr/>
+          <p:nvPr/>
+        </p:nvSpPr>
+        <p:spPr>
+          <a:xfrm>
+            <a:off x="14660974" y="0"/>
+            <a:ext cx="3657600" cy="3657600"/>
+          </a:xfrm>
+          <a:custGeom>
+            <a:avLst/>
+            <a:gdLst/>
+            <a:ahLst/>
+            <a:cxnLst/>
+            <a:rect l="l" t="t" r="r" b="b"/>
+            <a:pathLst>
+              <a:path w="4114800" h="4114800">
+                <a:moveTo>
+                  <a:pt x="0" y="0"/>
+                </a:moveTo>
+                <a:lnTo>
+                  <a:pt x="4114800" y="0"/>
+                </a:lnTo>
+                <a:lnTo>
+                  <a:pt x="4114800" y="4114800"/>
+                </a:lnTo>
+                <a:lnTo>
+                  <a:pt x="0" y="4114800"/>
+                </a:lnTo>
+                <a:lnTo>
+                  <a:pt x="0" y="0"/>
+                </a:lnTo>
+                <a:close/>
+              </a:path>
+            </a:pathLst>
+          </a:custGeom>
+          <a:blipFill>
+            <a:blip>
+              <a:alphaModFix amt="24000"/>
+              <a:extLst>
+                <a:ext uri="{96DAC541-7B7A-43D3-8B79-37D633B846F1}">
+                  <asvg:svgBlip xmlns:asvg="http://schemas.microsoft.com/office/drawing/2016/SVG/main" r:embed="rId5"/>
+                </a:ext>
+              </a:extLst>
+            </a:blip>
+            <a:stretch>
+              <a:fillRect/>
+            </a:stretch>
+          </a:blipFill>
+        </p:spPr>
+        <p:txBody>
+          <a:bodyPr/>
+          <a:lstStyle/>
+          <a:p>
+            <a:endParaRPr lang="en-CA"/>
+          </a:p>
+        </p:txBody>
+      </p:sp>
+      <p:sp>
+        <p:nvSpPr>
+          <p:cNvPr id="17" name="TextBox 20">
+            <a:extLst>
+              <a:ext uri="{FF2B5EF4-FFF2-40B4-BE49-F238E27FC236}">
+                <a16:creationId xmlns:a16="http://schemas.microsoft.com/office/drawing/2014/main" id="{E89D0632-A6F1-9573-29B4-CA6D9FC1366D}"/>
+              </a:ext>
+            </a:extLst>
+          </p:cNvPr>
+          <p:cNvSpPr txBox="1"/>
+          <p:nvPr/>
+        </p:nvSpPr>
+        <p:spPr>
+          <a:xfrm>
+            <a:off x="4841491" y="8696410"/>
+            <a:ext cx="4112539" cy="369332"/>
+          </a:xfrm>
+          <a:prstGeom prst="rect">
+            <a:avLst/>
+          </a:prstGeom>
+        </p:spPr>
+        <p:txBody>
+          <a:bodyPr wrap="square" lIns="0" tIns="0" rIns="0" bIns="0" rtlCol="0" anchor="t">
+            <a:spAutoFit/>
+          </a:bodyPr>
+          <a:lstStyle/>
+          <a:p>
+            <a:pPr marL="259080" lvl="1">
+              <a:lnSpc>
+                <a:spcPct val="100000"/>
+              </a:lnSpc>
+              <a:spcBef>
+                <a:spcPct val="0"/>
+              </a:spcBef>
+            </a:pPr>
+            <a:r>
+              <a:rPr lang="en-KR" sz="2400" dirty="0"/>
+              <a:t>(Tucker, 2024; Rescorla, 2018)</a:t>
             </a:r>
             <a:endParaRPr lang="en-US" sz="2400" dirty="0">
               <a:solidFill>
@@ -8755,14 +8980,14 @@
       </p:sp>
       <p:sp>
         <p:nvSpPr>
-          <p:cNvPr id="5" name="Freeform 5"/>
+          <p:cNvPr id="6" name="Freeform 6"/>
           <p:cNvSpPr/>
           <p:nvPr/>
         </p:nvSpPr>
         <p:spPr>
           <a:xfrm>
-            <a:off x="14784030" y="-62821"/>
-            <a:ext cx="3612154" cy="3612154"/>
+            <a:off x="57095" y="7695024"/>
+            <a:ext cx="2364367" cy="2364367"/>
           </a:xfrm>
           <a:custGeom>
             <a:avLst/>
@@ -8771,18 +8996,18 @@
             <a:cxnLst/>
             <a:rect l="l" t="t" r="r" b="b"/>
             <a:pathLst>
-              <a:path w="4114800" h="4114800">
+              <a:path w="2693378" h="2693378">
                 <a:moveTo>
                   <a:pt x="0" y="0"/>
                 </a:moveTo>
                 <a:lnTo>
-                  <a:pt x="4114800" y="0"/>
-                </a:lnTo>
-                <a:lnTo>
-                  <a:pt x="4114800" y="4114800"/>
-                </a:lnTo>
-                <a:lnTo>
-                  <a:pt x="0" y="4114800"/>
+                  <a:pt x="2693378" y="0"/>
+                </a:lnTo>
+                <a:lnTo>
+                  <a:pt x="2693378" y="2693378"/>
+                </a:lnTo>
+                <a:lnTo>
+                  <a:pt x="0" y="2693378"/>
                 </a:lnTo>
                 <a:lnTo>
                   <a:pt x="0" y="0"/>
@@ -8815,66 +9040,6 @@
       </p:sp>
       <p:sp>
         <p:nvSpPr>
-          <p:cNvPr id="6" name="Freeform 6"/>
-          <p:cNvSpPr/>
-          <p:nvPr/>
-        </p:nvSpPr>
-        <p:spPr>
-          <a:xfrm>
-            <a:off x="57095" y="7695024"/>
-            <a:ext cx="2364367" cy="2364367"/>
-          </a:xfrm>
-          <a:custGeom>
-            <a:avLst/>
-            <a:gdLst/>
-            <a:ahLst/>
-            <a:cxnLst/>
-            <a:rect l="l" t="t" r="r" b="b"/>
-            <a:pathLst>
-              <a:path w="2693378" h="2693378">
-                <a:moveTo>
-                  <a:pt x="0" y="0"/>
-                </a:moveTo>
-                <a:lnTo>
-                  <a:pt x="2693378" y="0"/>
-                </a:lnTo>
-                <a:lnTo>
-                  <a:pt x="2693378" y="2693378"/>
-                </a:lnTo>
-                <a:lnTo>
-                  <a:pt x="0" y="2693378"/>
-                </a:lnTo>
-                <a:lnTo>
-                  <a:pt x="0" y="0"/>
-                </a:lnTo>
-                <a:close/>
-              </a:path>
-            </a:pathLst>
-          </a:custGeom>
-          <a:blipFill>
-            <a:blip>
-              <a:alphaModFix amt="24000"/>
-              <a:extLst>
-                <a:ext uri="{96DAC541-7B7A-43D3-8B79-37D633B846F1}">
-                  <asvg:svgBlip xmlns:asvg="http://schemas.microsoft.com/office/drawing/2016/SVG/main" r:embed="rId5"/>
-                </a:ext>
-              </a:extLst>
-            </a:blip>
-            <a:stretch>
-              <a:fillRect/>
-            </a:stretch>
-          </a:blipFill>
-        </p:spPr>
-        <p:txBody>
-          <a:bodyPr/>
-          <a:lstStyle/>
-          <a:p>
-            <a:endParaRPr lang="en-CA"/>
-          </a:p>
-        </p:txBody>
-      </p:sp>
-      <p:sp>
-        <p:nvSpPr>
           <p:cNvPr id="10" name="Freeform 10"/>
           <p:cNvSpPr/>
           <p:nvPr/>
@@ -8975,7 +9140,7 @@
         </p:nvSpPr>
         <p:spPr>
           <a:xfrm>
-            <a:off x="4179008" y="2055933"/>
+            <a:off x="3900070" y="2293510"/>
             <a:ext cx="7681682" cy="961802"/>
           </a:xfrm>
           <a:prstGeom prst="rect">
@@ -9889,7 +10054,7 @@
         </p:nvSpPr>
         <p:spPr>
           <a:xfrm>
-            <a:off x="3228113" y="9557594"/>
+            <a:off x="4305693" y="9648559"/>
             <a:ext cx="2247507" cy="369332"/>
           </a:xfrm>
           <a:prstGeom prst="rect">
@@ -9940,7 +10105,7 @@
         </p:nvSpPr>
         <p:spPr>
           <a:xfrm>
-            <a:off x="12461813" y="9645064"/>
+            <a:off x="6424301" y="9486288"/>
             <a:ext cx="5021925" cy="496739"/>
           </a:xfrm>
           <a:prstGeom prst="rect">
@@ -9997,6 +10162,72 @@
               </a:rPr>
               <a:t>, n.d.; Rescorla, 2018)</a:t>
             </a:r>
+          </a:p>
+        </p:txBody>
+      </p:sp>
+      <p:sp>
+        <p:nvSpPr>
+          <p:cNvPr id="7" name="Freeform 5">
+            <a:extLst>
+              <a:ext uri="{FF2B5EF4-FFF2-40B4-BE49-F238E27FC236}">
+                <a16:creationId xmlns:a16="http://schemas.microsoft.com/office/drawing/2014/main" id="{27BCBECB-B76B-4F88-7028-B6DB71721B56}"/>
+              </a:ext>
+            </a:extLst>
+          </p:cNvPr>
+          <p:cNvSpPr/>
+          <p:nvPr/>
+        </p:nvSpPr>
+        <p:spPr>
+          <a:xfrm>
+            <a:off x="14660974" y="0"/>
+            <a:ext cx="3657600" cy="3657600"/>
+          </a:xfrm>
+          <a:custGeom>
+            <a:avLst/>
+            <a:gdLst/>
+            <a:ahLst/>
+            <a:cxnLst/>
+            <a:rect l="l" t="t" r="r" b="b"/>
+            <a:pathLst>
+              <a:path w="4114800" h="4114800">
+                <a:moveTo>
+                  <a:pt x="0" y="0"/>
+                </a:moveTo>
+                <a:lnTo>
+                  <a:pt x="4114800" y="0"/>
+                </a:lnTo>
+                <a:lnTo>
+                  <a:pt x="4114800" y="4114800"/>
+                </a:lnTo>
+                <a:lnTo>
+                  <a:pt x="0" y="4114800"/>
+                </a:lnTo>
+                <a:lnTo>
+                  <a:pt x="0" y="0"/>
+                </a:lnTo>
+                <a:close/>
+              </a:path>
+            </a:pathLst>
+          </a:custGeom>
+          <a:blipFill>
+            <a:blip>
+              <a:alphaModFix amt="24000"/>
+              <a:extLst>
+                <a:ext uri="{96DAC541-7B7A-43D3-8B79-37D633B846F1}">
+                  <asvg:svgBlip xmlns:asvg="http://schemas.microsoft.com/office/drawing/2016/SVG/main" r:embed="rId5"/>
+                </a:ext>
+              </a:extLst>
+            </a:blip>
+            <a:stretch>
+              <a:fillRect/>
+            </a:stretch>
+          </a:blipFill>
+        </p:spPr>
+        <p:txBody>
+          <a:bodyPr/>
+          <a:lstStyle/>
+          <a:p>
+            <a:endParaRPr lang="en-CA"/>
           </a:p>
         </p:txBody>
       </p:sp>
@@ -10204,14 +10435,14 @@
       </p:sp>
       <p:sp>
         <p:nvSpPr>
-          <p:cNvPr id="5" name="Freeform 5"/>
+          <p:cNvPr id="6" name="Freeform 6"/>
           <p:cNvSpPr/>
           <p:nvPr/>
         </p:nvSpPr>
         <p:spPr>
           <a:xfrm>
-            <a:off x="14718536" y="-44175"/>
-            <a:ext cx="3612154" cy="3700072"/>
+            <a:off x="57095" y="7637478"/>
+            <a:ext cx="2364367" cy="2421914"/>
           </a:xfrm>
           <a:custGeom>
             <a:avLst/>
@@ -10220,18 +10451,18 @@
             <a:cxnLst/>
             <a:rect l="l" t="t" r="r" b="b"/>
             <a:pathLst>
-              <a:path w="4114800" h="4114800">
+              <a:path w="2693378" h="2693378">
                 <a:moveTo>
                   <a:pt x="0" y="0"/>
                 </a:moveTo>
                 <a:lnTo>
-                  <a:pt x="4114800" y="0"/>
-                </a:lnTo>
-                <a:lnTo>
-                  <a:pt x="4114800" y="4114800"/>
-                </a:lnTo>
-                <a:lnTo>
-                  <a:pt x="0" y="4114800"/>
+                  <a:pt x="2693378" y="0"/>
+                </a:lnTo>
+                <a:lnTo>
+                  <a:pt x="2693378" y="2693378"/>
+                </a:lnTo>
+                <a:lnTo>
+                  <a:pt x="0" y="2693378"/>
                 </a:lnTo>
                 <a:lnTo>
                   <a:pt x="0" y="0"/>
@@ -10264,74 +10495,14 @@
       </p:sp>
       <p:sp>
         <p:nvSpPr>
-          <p:cNvPr id="6" name="Freeform 6"/>
-          <p:cNvSpPr/>
-          <p:nvPr/>
-        </p:nvSpPr>
-        <p:spPr>
-          <a:xfrm>
-            <a:off x="57095" y="7637478"/>
-            <a:ext cx="2364367" cy="2421914"/>
-          </a:xfrm>
-          <a:custGeom>
-            <a:avLst/>
-            <a:gdLst/>
-            <a:ahLst/>
-            <a:cxnLst/>
-            <a:rect l="l" t="t" r="r" b="b"/>
-            <a:pathLst>
-              <a:path w="2693378" h="2693378">
-                <a:moveTo>
-                  <a:pt x="0" y="0"/>
-                </a:moveTo>
-                <a:lnTo>
-                  <a:pt x="2693378" y="0"/>
-                </a:lnTo>
-                <a:lnTo>
-                  <a:pt x="2693378" y="2693378"/>
-                </a:lnTo>
-                <a:lnTo>
-                  <a:pt x="0" y="2693378"/>
-                </a:lnTo>
-                <a:lnTo>
-                  <a:pt x="0" y="0"/>
-                </a:lnTo>
-                <a:close/>
-              </a:path>
-            </a:pathLst>
-          </a:custGeom>
-          <a:blipFill>
-            <a:blip>
-              <a:alphaModFix amt="24000"/>
-              <a:extLst>
-                <a:ext uri="{96DAC541-7B7A-43D3-8B79-37D633B846F1}">
-                  <asvg:svgBlip xmlns:asvg="http://schemas.microsoft.com/office/drawing/2016/SVG/main" r:embed="rId5"/>
-                </a:ext>
-              </a:extLst>
-            </a:blip>
-            <a:stretch>
-              <a:fillRect/>
-            </a:stretch>
-          </a:blipFill>
-        </p:spPr>
-        <p:txBody>
-          <a:bodyPr/>
-          <a:lstStyle/>
-          <a:p>
-            <a:endParaRPr lang="en-CA"/>
-          </a:p>
-        </p:txBody>
-      </p:sp>
-      <p:sp>
-        <p:nvSpPr>
           <p:cNvPr id="11" name="TextBox 11"/>
           <p:cNvSpPr txBox="1"/>
           <p:nvPr/>
         </p:nvSpPr>
         <p:spPr>
           <a:xfrm>
-            <a:off x="2023537" y="510141"/>
-            <a:ext cx="12112681" cy="2205732"/>
+            <a:off x="1239278" y="867788"/>
+            <a:ext cx="12840818" cy="2205732"/>
           </a:xfrm>
           <a:prstGeom prst="rect">
             <a:avLst/>
@@ -10749,7 +10920,7 @@
         </p:nvSpPr>
         <p:spPr>
           <a:xfrm>
-            <a:off x="9753600" y="9969254"/>
+            <a:off x="9906000" y="9977675"/>
             <a:ext cx="2974037" cy="369332"/>
           </a:xfrm>
           <a:prstGeom prst="rect">
@@ -10791,6 +10962,72 @@
               <a:cs typeface="Open Sans"/>
               <a:sym typeface="Open Sans"/>
             </a:endParaRPr>
+          </a:p>
+        </p:txBody>
+      </p:sp>
+      <p:sp>
+        <p:nvSpPr>
+          <p:cNvPr id="10" name="Freeform 5">
+            <a:extLst>
+              <a:ext uri="{FF2B5EF4-FFF2-40B4-BE49-F238E27FC236}">
+                <a16:creationId xmlns:a16="http://schemas.microsoft.com/office/drawing/2014/main" id="{C4CBE676-DE98-AD34-9C0C-AB4DBB219DEC}"/>
+              </a:ext>
+            </a:extLst>
+          </p:cNvPr>
+          <p:cNvSpPr/>
+          <p:nvPr/>
+        </p:nvSpPr>
+        <p:spPr>
+          <a:xfrm>
+            <a:off x="14660974" y="0"/>
+            <a:ext cx="3657600" cy="3657600"/>
+          </a:xfrm>
+          <a:custGeom>
+            <a:avLst/>
+            <a:gdLst/>
+            <a:ahLst/>
+            <a:cxnLst/>
+            <a:rect l="l" t="t" r="r" b="b"/>
+            <a:pathLst>
+              <a:path w="4114800" h="4114800">
+                <a:moveTo>
+                  <a:pt x="0" y="0"/>
+                </a:moveTo>
+                <a:lnTo>
+                  <a:pt x="4114800" y="0"/>
+                </a:lnTo>
+                <a:lnTo>
+                  <a:pt x="4114800" y="4114800"/>
+                </a:lnTo>
+                <a:lnTo>
+                  <a:pt x="0" y="4114800"/>
+                </a:lnTo>
+                <a:lnTo>
+                  <a:pt x="0" y="0"/>
+                </a:lnTo>
+                <a:close/>
+              </a:path>
+            </a:pathLst>
+          </a:custGeom>
+          <a:blipFill>
+            <a:blip>
+              <a:alphaModFix amt="24000"/>
+              <a:extLst>
+                <a:ext uri="{96DAC541-7B7A-43D3-8B79-37D633B846F1}">
+                  <asvg:svgBlip xmlns:asvg="http://schemas.microsoft.com/office/drawing/2016/SVG/main" r:embed="rId5"/>
+                </a:ext>
+              </a:extLst>
+            </a:blip>
+            <a:stretch>
+              <a:fillRect/>
+            </a:stretch>
+          </a:blipFill>
+        </p:spPr>
+        <p:txBody>
+          <a:bodyPr/>
+          <a:lstStyle/>
+          <a:p>
+            <a:endParaRPr lang="en-CA"/>
           </a:p>
         </p:txBody>
       </p:sp>
@@ -10998,14 +11235,14 @@
       </p:sp>
       <p:sp>
         <p:nvSpPr>
-          <p:cNvPr id="5" name="Freeform 5"/>
+          <p:cNvPr id="6" name="Freeform 6"/>
           <p:cNvSpPr/>
           <p:nvPr/>
         </p:nvSpPr>
         <p:spPr>
           <a:xfrm>
-            <a:off x="14716060" y="-1"/>
-            <a:ext cx="3612154" cy="3641629"/>
+            <a:off x="57095" y="7675732"/>
+            <a:ext cx="2364367" cy="2383660"/>
           </a:xfrm>
           <a:custGeom>
             <a:avLst/>
@@ -11014,18 +11251,18 @@
             <a:cxnLst/>
             <a:rect l="l" t="t" r="r" b="b"/>
             <a:pathLst>
-              <a:path w="4114800" h="4114800">
+              <a:path w="2693378" h="2693378">
                 <a:moveTo>
                   <a:pt x="0" y="0"/>
                 </a:moveTo>
                 <a:lnTo>
-                  <a:pt x="4114800" y="0"/>
-                </a:lnTo>
-                <a:lnTo>
-                  <a:pt x="4114800" y="4114800"/>
-                </a:lnTo>
-                <a:lnTo>
-                  <a:pt x="0" y="4114800"/>
+                  <a:pt x="2693378" y="0"/>
+                </a:lnTo>
+                <a:lnTo>
+                  <a:pt x="2693378" y="2693378"/>
+                </a:lnTo>
+                <a:lnTo>
+                  <a:pt x="0" y="2693378"/>
                 </a:lnTo>
                 <a:lnTo>
                   <a:pt x="0" y="0"/>
@@ -11058,14 +11295,61 @@
       </p:sp>
       <p:sp>
         <p:nvSpPr>
-          <p:cNvPr id="6" name="Freeform 6"/>
+          <p:cNvPr id="12" name="TextBox 12"/>
+          <p:cNvSpPr txBox="1"/>
+          <p:nvPr/>
+        </p:nvSpPr>
+        <p:spPr>
+          <a:xfrm>
+            <a:off x="6424633" y="1269380"/>
+            <a:ext cx="5438733" cy="1102866"/>
+          </a:xfrm>
+          <a:prstGeom prst="rect">
+            <a:avLst/>
+          </a:prstGeom>
+        </p:spPr>
+        <p:txBody>
+          <a:bodyPr wrap="square" lIns="0" tIns="0" rIns="0" bIns="0" rtlCol="0" anchor="t">
+            <a:spAutoFit/>
+          </a:bodyPr>
+          <a:lstStyle/>
+          <a:p>
+            <a:pPr algn="l">
+              <a:lnSpc>
+                <a:spcPts val="8560"/>
+              </a:lnSpc>
+            </a:pPr>
+            <a:r>
+              <a:rPr lang="en-US" sz="8000" b="1" dirty="0">
+                <a:solidFill>
+                  <a:srgbClr val="000000"/>
+                </a:solidFill>
+                <a:latin typeface="Alegreya Sans SC Bold"/>
+                <a:ea typeface="Alegreya Sans SC Bold"/>
+                <a:cs typeface="Alegreya Sans SC Bold"/>
+                <a:sym typeface="Alegreya Sans SC Bold"/>
+              </a:rPr>
+              <a:t>Closing Off</a:t>
+            </a:r>
+          </a:p>
+        </p:txBody>
+      </p:sp>
+      <p:sp>
+        <p:nvSpPr>
+          <p:cNvPr id="8" name="Freeform 5">
+            <a:extLst>
+              <a:ext uri="{FF2B5EF4-FFF2-40B4-BE49-F238E27FC236}">
+                <a16:creationId xmlns:a16="http://schemas.microsoft.com/office/drawing/2014/main" id="{D17AEF4A-198A-1492-42D2-C8E99F8EAF9E}"/>
+              </a:ext>
+            </a:extLst>
+          </p:cNvPr>
           <p:cNvSpPr/>
           <p:nvPr/>
         </p:nvSpPr>
         <p:spPr>
           <a:xfrm>
-            <a:off x="57095" y="7675732"/>
-            <a:ext cx="2364367" cy="2383660"/>
+            <a:off x="14660974" y="0"/>
+            <a:ext cx="3657600" cy="3657600"/>
           </a:xfrm>
           <a:custGeom>
             <a:avLst/>
@@ -11074,18 +11358,18 @@
             <a:cxnLst/>
             <a:rect l="l" t="t" r="r" b="b"/>
             <a:pathLst>
-              <a:path w="2693378" h="2693378">
+              <a:path w="4114800" h="4114800">
                 <a:moveTo>
                   <a:pt x="0" y="0"/>
                 </a:moveTo>
                 <a:lnTo>
-                  <a:pt x="2693378" y="0"/>
-                </a:lnTo>
-                <a:lnTo>
-                  <a:pt x="2693378" y="2693378"/>
-                </a:lnTo>
-                <a:lnTo>
-                  <a:pt x="0" y="2693378"/>
+                  <a:pt x="4114800" y="0"/>
+                </a:lnTo>
+                <a:lnTo>
+                  <a:pt x="4114800" y="4114800"/>
+                </a:lnTo>
+                <a:lnTo>
+                  <a:pt x="0" y="4114800"/>
                 </a:lnTo>
                 <a:lnTo>
                   <a:pt x="0" y="0"/>
@@ -11113,47 +11397,6 @@
           <a:lstStyle/>
           <a:p>
             <a:endParaRPr lang="en-CA"/>
-          </a:p>
-        </p:txBody>
-      </p:sp>
-      <p:sp>
-        <p:nvSpPr>
-          <p:cNvPr id="12" name="TextBox 12"/>
-          <p:cNvSpPr txBox="1"/>
-          <p:nvPr/>
-        </p:nvSpPr>
-        <p:spPr>
-          <a:xfrm>
-            <a:off x="6424633" y="1269380"/>
-            <a:ext cx="5438733" cy="1102866"/>
-          </a:xfrm>
-          <a:prstGeom prst="rect">
-            <a:avLst/>
-          </a:prstGeom>
-        </p:spPr>
-        <p:txBody>
-          <a:bodyPr wrap="square" lIns="0" tIns="0" rIns="0" bIns="0" rtlCol="0" anchor="t">
-            <a:spAutoFit/>
-          </a:bodyPr>
-          <a:lstStyle/>
-          <a:p>
-            <a:pPr algn="l">
-              <a:lnSpc>
-                <a:spcPts val="8560"/>
-              </a:lnSpc>
-            </a:pPr>
-            <a:r>
-              <a:rPr lang="en-US" sz="8000" b="1" dirty="0">
-                <a:solidFill>
-                  <a:srgbClr val="000000"/>
-                </a:solidFill>
-                <a:latin typeface="Alegreya Sans SC Bold"/>
-                <a:ea typeface="Alegreya Sans SC Bold"/>
-                <a:cs typeface="Alegreya Sans SC Bold"/>
-                <a:sym typeface="Alegreya Sans SC Bold"/>
-              </a:rPr>
-              <a:t>Closing Off</a:t>
-            </a:r>
           </a:p>
         </p:txBody>
       </p:sp>
@@ -11208,7 +11451,7 @@
         </p:nvSpPr>
         <p:spPr>
           <a:xfrm>
-            <a:off x="2421462" y="9570317"/>
+            <a:off x="2133600" y="9610720"/>
             <a:ext cx="2870724" cy="369332"/>
           </a:xfrm>
           <a:prstGeom prst="rect">

</xml_diff>